<commit_message>
Deck: live queue figure (0.13%); STATUS: M0 is live
Co-Authored-By: Claude Opus 5.5 (1M context) <noreply@anthropic.com>
</commit_message>
<xml_diff>
--- a/docs/deck/DRISHTI_SIH26102_v2.pptx
+++ b/docs/deck/DRISHTI_SIH26102_v2.pptx
@@ -859,7 +859,7 @@
           <a:p>
             <a:r>
               <a:rPr lang="en-US" dirty="0"/>
-              <a:t>Measured on the real eSAKSHI export in the prototype (2026-09-25): 2,09,993 works screened; 847 (0.40%) flagged Medium for review by the cost and record checks, none High yet. 'Two in three': about two-thirds of completed works carry an attachment on eSAKSHI (65.9% of completed 18th Lok Sabha works in the export).</a:t>
+              <a:t>Measured on the real eSAKSHI export in the live prototype (2026-09-26): 2,09,993 works screened; 276 (0.13%) flagged Medium for review (253 on price), none High yet. Date errors from bulk entry when eSAKSHI opened are listed once per office (22 offices) instead of filling the queue. 'Two in three': about two-thirds of completed works carry an attachment on eSAKSHI (65.9% of completed 18th Lok Sabha works in the export).</a:t>
             </a:r>
             <a:endParaRPr lang="en-US" dirty="0"/>
           </a:p>
@@ -13184,7 +13184,7 @@
           <a:p>
             <a:pPr algn="l" marL="177800" indent="-177800">
               <a:spcAft>
-                <a:spcPts val="400"/>
+                <a:spcPts val="200"/>
               </a:spcAft>
               <a:buSzPct val="100000"/>
               <a:buChar char="•"/>
@@ -13205,7 +13205,7 @@
           <a:p>
             <a:pPr algn="l" marL="177800" indent="-177800">
               <a:spcAft>
-                <a:spcPts val="400"/>
+                <a:spcPts val="200"/>
               </a:spcAft>
               <a:buSzPct val="100000"/>
               <a:buChar char="•"/>
@@ -13226,7 +13226,7 @@
           <a:p>
             <a:pPr algn="l" marL="177800" indent="-177800">
               <a:spcAft>
-                <a:spcPts val="400"/>
+                <a:spcPts val="200"/>
               </a:spcAft>
               <a:buSzPct val="100000"/>
               <a:buChar char="•"/>
@@ -13247,7 +13247,7 @@
           <a:p>
             <a:pPr algn="l" marL="177800" indent="-177800">
               <a:spcAft>
-                <a:spcPts val="400"/>
+                <a:spcPts val="200"/>
               </a:spcAft>
               <a:buSzPct val="100000"/>
               <a:buChar char="•"/>
@@ -13261,7 +13261,7 @@
                 <a:ea typeface="Calibri" pitchFamily="34" charset="-122"/>
                 <a:cs typeface="Calibri" pitchFamily="34" charset="-120"/>
               </a:rPr>
-              <a:t>Every agent's accuracy tracked openly</a:t>
+              <a:t>Agent accuracy tracked openly</a:t>
             </a:r>
             <a:endParaRPr lang="en-US" sz="1750" dirty="0"/>
           </a:p>
@@ -13395,7 +13395,7 @@
           <a:p>
             <a:pPr algn="l" marL="177800" indent="-177800">
               <a:spcAft>
-                <a:spcPts val="400"/>
+                <a:spcPts val="200"/>
               </a:spcAft>
               <a:buSzPct val="100000"/>
               <a:buChar char="•"/>
@@ -13416,7 +13416,7 @@
           <a:p>
             <a:pPr algn="l" marL="177800" indent="-177800">
               <a:spcAft>
-                <a:spcPts val="400"/>
+                <a:spcPts val="200"/>
               </a:spcAft>
               <a:buSzPct val="100000"/>
               <a:buChar char="•"/>
@@ -13437,7 +13437,7 @@
           <a:p>
             <a:pPr algn="l" marL="177800" indent="-177800">
               <a:spcAft>
-                <a:spcPts val="400"/>
+                <a:spcPts val="200"/>
               </a:spcAft>
               <a:buSzPct val="100000"/>
               <a:buChar char="•"/>
@@ -13458,7 +13458,7 @@
           <a:p>
             <a:pPr algn="l" marL="177800" indent="-177800">
               <a:spcAft>
-                <a:spcPts val="400"/>
+                <a:spcPts val="200"/>
               </a:spcAft>
               <a:buSzPct val="100000"/>
               <a:buChar char="•"/>
@@ -13606,7 +13606,7 @@
           <a:p>
             <a:pPr algn="l" marL="177800" indent="-177800">
               <a:spcAft>
-                <a:spcPts val="400"/>
+                <a:spcPts val="200"/>
               </a:spcAft>
               <a:buSzPct val="100000"/>
               <a:buChar char="•"/>
@@ -13627,7 +13627,7 @@
           <a:p>
             <a:pPr algn="l" marL="177800" indent="-177800">
               <a:spcAft>
-                <a:spcPts val="400"/>
+                <a:spcPts val="200"/>
               </a:spcAft>
               <a:buSzPct val="100000"/>
               <a:buChar char="•"/>
@@ -13648,7 +13648,7 @@
           <a:p>
             <a:pPr algn="l" marL="177800" indent="-177800">
               <a:spcAft>
-                <a:spcPts val="400"/>
+                <a:spcPts val="200"/>
               </a:spcAft>
               <a:buSzPct val="100000"/>
               <a:buChar char="•"/>
@@ -13669,7 +13669,7 @@
           <a:p>
             <a:pPr algn="l" marL="177800" indent="-177800">
               <a:spcAft>
-                <a:spcPts val="400"/>
+                <a:spcPts val="200"/>
               </a:spcAft>
               <a:buSzPct val="100000"/>
               <a:buChar char="•"/>
@@ -13817,7 +13817,7 @@
           <a:p>
             <a:pPr algn="l" marL="177800" indent="-177800">
               <a:spcAft>
-                <a:spcPts val="400"/>
+                <a:spcPts val="200"/>
               </a:spcAft>
               <a:buSzPct val="100000"/>
               <a:buChar char="•"/>
@@ -13838,7 +13838,7 @@
           <a:p>
             <a:pPr algn="l" marL="177800" indent="-177800">
               <a:spcAft>
-                <a:spcPts val="400"/>
+                <a:spcPts val="200"/>
               </a:spcAft>
               <a:buSzPct val="100000"/>
               <a:buChar char="•"/>
@@ -13859,7 +13859,7 @@
           <a:p>
             <a:pPr algn="l" marL="177800" indent="-177800">
               <a:spcAft>
-                <a:spcPts val="400"/>
+                <a:spcPts val="200"/>
               </a:spcAft>
               <a:buSzPct val="100000"/>
               <a:buChar char="•"/>
@@ -13880,7 +13880,7 @@
           <a:p>
             <a:pPr algn="l" marL="177800" indent="-177800">
               <a:spcAft>
-                <a:spcPts val="400"/>
+                <a:spcPts val="200"/>
               </a:spcAft>
               <a:buSzPct val="100000"/>
               <a:buChar char="•"/>
@@ -14751,7 +14751,7 @@
                 <a:ea typeface="Cambria" pitchFamily="34" charset="-122"/>
                 <a:cs typeface="Cambria" pitchFamily="34" charset="-120"/>
               </a:rPr>
-              <a:t>0.4%</a:t>
+              <a:t>0.13%</a:t>
             </a:r>
             <a:endParaRPr lang="en-US" sz="3150" dirty="0"/>
           </a:p>

</xml_diff>

<commit_message>
Show the product only: remove competitor comparisons from docs, deck and trial notes
- README, AGENTS, HOW-IT-WORKS, FINDINGS, GLOSSARY, CONTRIBUTING, STATUS: results stated on
  their own, no rival methods or "better than" claims
- Deck slide 6: "Comparison with existing systems" grid replaced by "What DRISHTI checks - and how";
  "beat a baseline" wording replaced by "meet its accuracy target"
- v2 design spec: rival review and head-to-head plan removed
- Trial script comments neutral

Co-Authored-By: Claude Opus 5.5 (1M context) <noreply@anthropic.com>
</commit_message>
<xml_diff>
--- a/docs/deck/DRISHTI_SIH26102_v2.pptx
+++ b/docs/deck/DRISHTI_SIH26102_v2.pptx
@@ -683,7 +683,7 @@
           <a:p>
             <a:r>
               <a:rPr lang="en-US" dirty="0"/>
-              <a:t>Stage order: before sanction (Eligibility, Duplicate &amp; Split, Cost); during construction (Site Progress, Photo Forensics, Geo-Location, Document, Satellite); money &amp; time (Delay Prediction, Fund Flow, Contractor Network); after completion (Citizen Verification). Each agent is tested on held-out real data against the method a typical team would use (Isolation Forest, TF-IDF duplicates, 64-bit photo hashes, deadline rules) and stays switched off if it does not beat it.</a:t>
+              <a:t>Stage order: before sanction (Eligibility, Duplicate &amp; Split, Cost); during construction (Site Progress, Photo Forensics, Geo-Location, Document, Satellite); money &amp; time (Delay Prediction, Fund Flow, Contractor Network); after completion (Citizen Verification). Each agent is tested on held-out real eSAKSHI data and stays switched off until it meets its accuracy target.</a:t>
             </a:r>
             <a:endParaRPr lang="en-US" dirty="0"/>
           </a:p>
@@ -947,7 +947,7 @@
           <a:p>
             <a:r>
               <a:rPr lang="en-US" dirty="0"/>
-              <a:t>Checkmarks: eSAKSHI collects geo-tagged photos and citizen ratings but does not verify or use them (21,789 of 21,793 ratings on completed 18th LS works are zero) - hence 'Partial'. CAG figures are totals from the annexures of CAG Report No. 31 of 2010-11 (TOTAL rows, sampled districts): Annex 7.2 plaques not erected - 4,918 works in 31 District Authorities (Rs 100.20 crore); Annex 4.7 incomplete works - 12,006 works in 71 DAs, Rs 279.99 crore. The earlier '₹9.16 Cr on 518 works' figure was replaced because it could not be traced to that report; restore it if the team has the source. Outlay ~Rs 4,000 crore: PIB 2027330 (June 2024).</a:t>
+              <a:t>Citizen ratings on eSAKSHI are almost all empty (21,789 of 21,793 on completed 18th LS works are zero), so citizen confirmation is a new channel. CAG figures are totals from the annexures of CAG Report No. 31 of 2010-11 (TOTAL rows, sampled districts): Annex 7.2 plaques not erected - 4,918 works in 31 District Authorities (Rs 100.20 crore); Annex 4.7 incomplete works - 12,006 works in 71 DAs, Rs 279.99 crore. The earlier '₹9.16 Cr on 518 works' figure was replaced because it could not be traced to that report; restore it if the team has the source. Outlay ~Rs 4,000 crore: PIB 2027330 (June 2024).</a:t>
             </a:r>
             <a:endParaRPr lang="en-US" dirty="0"/>
           </a:p>
@@ -3983,7 +3983,7 @@
                 <a:ea typeface="Calibri" pitchFamily="34" charset="-122"/>
                 <a:cs typeface="Calibri" pitchFamily="34" charset="-120"/>
               </a:rPr>
-              <a:t>methods India already runs at scale (PMAY-G, Amrit Sarovar); each agent must beat a baseline first.</a:t>
+              <a:t>methods India already runs at scale (PMAY-G, Amrit Sarovar); each agent is measured on real data first.</a:t>
             </a:r>
             <a:endParaRPr lang="en-US" sz="1820" dirty="0"/>
           </a:p>
@@ -12754,7 +12754,7 @@
                 <a:ea typeface="Calibri" pitchFamily="34" charset="-122"/>
                 <a:cs typeface="Calibri" pitchFamily="34" charset="-120"/>
               </a:rPr>
-              <a:t>Every agent is tested on real eSAKSHI data and must beat a simple baseline before it goes live. If it fails, it stays switched off.</a:t>
+              <a:t>Every agent is tested on real eSAKSHI data and must meet its accuracy target before it goes live. If it fails, it stays switched off.</a:t>
             </a:r>
             <a:endParaRPr lang="en-US" sz="1600" dirty="0"/>
           </a:p>
@@ -15232,7 +15232,7 @@
                 <a:ea typeface="Calibri" pitchFamily="34" charset="-122"/>
                 <a:cs typeface="Calibri" pitchFamily="34" charset="-120"/>
               </a:rPr>
-              <a:t>COMPARISON WITH EXISTING SYSTEMS</a:t>
+              <a:t>WHAT DRISHTI CHECKS — AND HOW</a:t>
             </a:r>
             <a:endParaRPr lang="en-US" sz="1720" dirty="0"/>
           </a:p>
@@ -15262,10 +15262,8 @@
               <a:tblPr/>
               <a:tblGrid>
                 <a:gridCol w="3810000"/>
-                <a:gridCol w="1625600"/>
-                <a:gridCol w="1625600"/>
-                <a:gridCol w="1625600"/>
-                <a:gridCol w="1612900"/>
+                <a:gridCol w="4572000"/>
+                <a:gridCol w="1917700"/>
               </a:tblGrid>
               <a:tr h="609600">
                 <a:tc>
@@ -15294,7 +15292,7 @@
                       </a:endParaRPr>
                     </a:p>
                   </a:txBody>
-                  <a:tcPr marL="76200" marR="76200" marT="0" marB="0" anchor="ctr">
+                  <a:tcPr marL="101600" marR="76200" marT="0" marB="0" anchor="ctr">
                     <a:lnL w="12700" cap="flat" cmpd="sng" algn="ctr">
                       <a:solidFill>
                         <a:srgbClr val="B1BBC8"/>
@@ -15341,7 +15339,7 @@
                     <a:bodyPr/>
                     <a:lstStyle/>
                     <a:p>
-                      <a:pPr algn="ctr" indent="0" marL="0">
+                      <a:pPr algn="l" indent="0" marL="0">
                         <a:buNone/>
                       </a:pPr>
                       <a:r>
@@ -15353,7 +15351,7 @@
                           <a:ea typeface="Calibri" pitchFamily="34" charset="-122"/>
                           <a:cs typeface="Calibri" pitchFamily="34" charset="-120"/>
                         </a:rPr>
-                        <a:t>DRISHTI</a:t>
+                        <a:t>How DRISHTI does it</a:t>
                       </a:r>
                       <a:endParaRPr lang="en-US" sz="1550" dirty="0">
                         <a:latin typeface="Calibri" charset="0"/>
@@ -15362,7 +15360,7 @@
                       </a:endParaRPr>
                     </a:p>
                   </a:txBody>
-                  <a:tcPr marL="76200" marR="76200" marT="0" marB="0" anchor="ctr">
+                  <a:tcPr marL="101600" marR="76200" marT="0" marB="0" anchor="ctr">
                     <a:lnL w="12700" cap="flat" cmpd="sng" algn="ctr">
                       <a:solidFill>
                         <a:srgbClr val="B1BBC8"/>
@@ -15409,7 +15407,7 @@
                     <a:bodyPr/>
                     <a:lstStyle/>
                     <a:p>
-                      <a:pPr algn="ctr" indent="0" marL="0">
+                      <a:pPr algn="l" indent="0" marL="0">
                         <a:buNone/>
                       </a:pPr>
                       <a:r>
@@ -15421,7 +15419,7 @@
                           <a:ea typeface="Calibri" pitchFamily="34" charset="-122"/>
                           <a:cs typeface="Calibri" pitchFamily="34" charset="-120"/>
                         </a:rPr>
-                        <a:t>eSAKSHI Portal</a:t>
+                        <a:t>Stage</a:t>
                       </a:r>
                       <a:endParaRPr lang="en-US" sz="1550" dirty="0">
                         <a:latin typeface="Calibri" charset="0"/>
@@ -15430,143 +15428,7 @@
                       </a:endParaRPr>
                     </a:p>
                   </a:txBody>
-                  <a:tcPr marL="76200" marR="76200" marT="0" marB="0" anchor="ctr">
-                    <a:lnL w="12700" cap="flat" cmpd="sng" algn="ctr">
-                      <a:solidFill>
-                        <a:srgbClr val="B1BBC8"/>
-                      </a:solidFill>
-                      <a:prstDash val="solid"/>
-                      <a:round/>
-                      <a:headEnd type="none" w="med" len="med"/>
-                      <a:tailEnd type="none" w="med" len="med"/>
-                    </a:lnL>
-                    <a:lnR w="12700" cap="flat" cmpd="sng" algn="ctr">
-                      <a:solidFill>
-                        <a:srgbClr val="B1BBC8"/>
-                      </a:solidFill>
-                      <a:prstDash val="solid"/>
-                      <a:round/>
-                      <a:headEnd type="none" w="med" len="med"/>
-                      <a:tailEnd type="none" w="med" len="med"/>
-                    </a:lnR>
-                    <a:lnT w="12700" cap="flat" cmpd="sng" algn="ctr">
-                      <a:solidFill>
-                        <a:srgbClr val="B1BBC8"/>
-                      </a:solidFill>
-                      <a:prstDash val="solid"/>
-                      <a:round/>
-                      <a:headEnd type="none" w="med" len="med"/>
-                      <a:tailEnd type="none" w="med" len="med"/>
-                    </a:lnT>
-                    <a:lnB w="12700" cap="flat" cmpd="sng" algn="ctr">
-                      <a:solidFill>
-                        <a:srgbClr val="B1BBC8"/>
-                      </a:solidFill>
-                      <a:prstDash val="solid"/>
-                      <a:round/>
-                      <a:headEnd type="none" w="med" len="med"/>
-                      <a:tailEnd type="none" w="med" len="med"/>
-                    </a:lnB>
-                    <a:solidFill>
-                      <a:srgbClr val="2A4D88"/>
-                    </a:solidFill>
-                  </a:tcPr>
-                </a:tc>
-                <a:tc>
-                  <a:txBody>
-                    <a:bodyPr/>
-                    <a:lstStyle/>
-                    <a:p>
-                      <a:pPr algn="ctr" indent="0" marL="0">
-                        <a:buNone/>
-                      </a:pPr>
-                      <a:r>
-                        <a:rPr lang="en-US" sz="1550" b="1" dirty="0">
-                          <a:solidFill>
-                            <a:srgbClr val="FFFFFF"/>
-                          </a:solidFill>
-                          <a:latin typeface="Calibri" pitchFamily="34" charset="0"/>
-                          <a:ea typeface="Calibri" pitchFamily="34" charset="-122"/>
-                          <a:cs typeface="Calibri" pitchFamily="34" charset="-120"/>
-                        </a:rPr>
-                        <a:t>Manual Audit / Inspection</a:t>
-                      </a:r>
-                      <a:endParaRPr lang="en-US" sz="1550" dirty="0">
-                        <a:latin typeface="Calibri" charset="0"/>
-                        <a:ea typeface="Calibri" charset="0"/>
-                        <a:cs typeface="Calibri" charset="0"/>
-                      </a:endParaRPr>
-                    </a:p>
-                  </a:txBody>
-                  <a:tcPr marL="76200" marR="76200" marT="0" marB="0" anchor="ctr">
-                    <a:lnL w="12700" cap="flat" cmpd="sng" algn="ctr">
-                      <a:solidFill>
-                        <a:srgbClr val="B1BBC8"/>
-                      </a:solidFill>
-                      <a:prstDash val="solid"/>
-                      <a:round/>
-                      <a:headEnd type="none" w="med" len="med"/>
-                      <a:tailEnd type="none" w="med" len="med"/>
-                    </a:lnL>
-                    <a:lnR w="12700" cap="flat" cmpd="sng" algn="ctr">
-                      <a:solidFill>
-                        <a:srgbClr val="B1BBC8"/>
-                      </a:solidFill>
-                      <a:prstDash val="solid"/>
-                      <a:round/>
-                      <a:headEnd type="none" w="med" len="med"/>
-                      <a:tailEnd type="none" w="med" len="med"/>
-                    </a:lnR>
-                    <a:lnT w="12700" cap="flat" cmpd="sng" algn="ctr">
-                      <a:solidFill>
-                        <a:srgbClr val="B1BBC8"/>
-                      </a:solidFill>
-                      <a:prstDash val="solid"/>
-                      <a:round/>
-                      <a:headEnd type="none" w="med" len="med"/>
-                      <a:tailEnd type="none" w="med" len="med"/>
-                    </a:lnT>
-                    <a:lnB w="12700" cap="flat" cmpd="sng" algn="ctr">
-                      <a:solidFill>
-                        <a:srgbClr val="B1BBC8"/>
-                      </a:solidFill>
-                      <a:prstDash val="solid"/>
-                      <a:round/>
-                      <a:headEnd type="none" w="med" len="med"/>
-                      <a:tailEnd type="none" w="med" len="med"/>
-                    </a:lnB>
-                    <a:solidFill>
-                      <a:srgbClr val="2A4D88"/>
-                    </a:solidFill>
-                  </a:tcPr>
-                </a:tc>
-                <a:tc>
-                  <a:txBody>
-                    <a:bodyPr/>
-                    <a:lstStyle/>
-                    <a:p>
-                      <a:pPr algn="ctr" indent="0" marL="0">
-                        <a:buNone/>
-                      </a:pPr>
-                      <a:r>
-                        <a:rPr lang="en-US" sz="1550" b="1" dirty="0">
-                          <a:solidFill>
-                            <a:srgbClr val="FFFFFF"/>
-                          </a:solidFill>
-                          <a:latin typeface="Calibri" pitchFamily="34" charset="0"/>
-                          <a:ea typeface="Calibri" pitchFamily="34" charset="-122"/>
-                          <a:cs typeface="Calibri" pitchFamily="34" charset="-120"/>
-                        </a:rPr>
-                        <a:t>Generic BI Dashboards</a:t>
-                      </a:r>
-                      <a:endParaRPr lang="en-US" sz="1550" dirty="0">
-                        <a:latin typeface="Calibri" charset="0"/>
-                        <a:ea typeface="Calibri" charset="0"/>
-                        <a:cs typeface="Calibri" charset="0"/>
-                      </a:endParaRPr>
-                    </a:p>
-                  </a:txBody>
-                  <a:tcPr marL="76200" marR="76200" marT="0" marB="0" anchor="ctr">
+                  <a:tcPr marL="101600" marR="76200" marT="0" marB="0" anchor="ctr">
                     <a:lnL w="12700" cap="flat" cmpd="sng" algn="ctr">
                       <a:solidFill>
                         <a:srgbClr val="B1BBC8"/>
@@ -15683,28 +15545,28 @@
                     <a:bodyPr/>
                     <a:lstStyle/>
                     <a:p>
-                      <a:pPr algn="ctr" indent="0" marL="0">
+                      <a:pPr indent="0" marL="0">
                         <a:buNone/>
                       </a:pPr>
                       <a:r>
-                        <a:rPr lang="en-US" sz="1900" dirty="0">
+                        <a:rPr lang="en-US" sz="1450" dirty="0">
                           <a:solidFill>
-                            <a:srgbClr val="2E7D4F"/>
+                            <a:srgbClr val="1A2F57"/>
                           </a:solidFill>
-                          <a:latin typeface="Segoe UI Symbol" pitchFamily="34" charset="0"/>
-                          <a:ea typeface="Segoe UI Symbol" pitchFamily="34" charset="-122"/>
-                          <a:cs typeface="Segoe UI Symbol" pitchFamily="34" charset="-120"/>
+                          <a:latin typeface="Calibri" pitchFamily="34" charset="0"/>
+                          <a:ea typeface="Calibri" pitchFamily="34" charset="-122"/>
+                          <a:cs typeface="Calibri" pitchFamily="34" charset="-120"/>
                         </a:rPr>
-                        <a:t>✓</a:t>
+                        <a:t>Cost range of similar works in the same district</a:t>
                       </a:r>
-                      <a:endParaRPr lang="en-US" sz="1900" dirty="0">
-                        <a:latin typeface="Segoe UI Symbol" charset="0"/>
-                        <a:ea typeface="Segoe UI Symbol" charset="0"/>
-                        <a:cs typeface="Segoe UI Symbol" charset="0"/>
+                      <a:endParaRPr lang="en-US" sz="1450" dirty="0">
+                        <a:latin typeface="Calibri" charset="0"/>
+                        <a:ea typeface="Calibri" charset="0"/>
+                        <a:cs typeface="Calibri" charset="0"/>
                       </a:endParaRPr>
                     </a:p>
                   </a:txBody>
-                  <a:tcPr marL="0" marR="0" marT="0" marB="0" anchor="ctr">
+                  <a:tcPr marL="101600" marR="76200" marT="0" marB="0" anchor="ctr">
                     <a:lnL w="12700" cap="flat" cmpd="sng" algn="ctr">
                       <a:solidFill>
                         <a:srgbClr val="B1BBC8"/>
@@ -15751,164 +15613,28 @@
                     <a:bodyPr/>
                     <a:lstStyle/>
                     <a:p>
-                      <a:pPr algn="ctr" indent="0" marL="0">
+                      <a:pPr indent="0" marL="0">
                         <a:buNone/>
                       </a:pPr>
                       <a:r>
-                        <a:rPr lang="en-US" sz="1900" dirty="0">
+                        <a:rPr lang="en-US" sz="1400" b="1" dirty="0">
                           <a:solidFill>
-                            <a:srgbClr val="B23B3B"/>
+                            <a:srgbClr val="2A4D88"/>
                           </a:solidFill>
-                          <a:latin typeface="Segoe UI Symbol" pitchFamily="34" charset="0"/>
-                          <a:ea typeface="Segoe UI Symbol" pitchFamily="34" charset="-122"/>
-                          <a:cs typeface="Segoe UI Symbol" pitchFamily="34" charset="-120"/>
+                          <a:latin typeface="Calibri" pitchFamily="34" charset="0"/>
+                          <a:ea typeface="Calibri" pitchFamily="34" charset="-122"/>
+                          <a:cs typeface="Calibri" pitchFamily="34" charset="-120"/>
                         </a:rPr>
-                        <a:t>✗</a:t>
+                        <a:t>Before sanction</a:t>
                       </a:r>
-                      <a:endParaRPr lang="en-US" sz="1900" dirty="0">
-                        <a:latin typeface="Segoe UI Symbol" charset="0"/>
-                        <a:ea typeface="Segoe UI Symbol" charset="0"/>
-                        <a:cs typeface="Segoe UI Symbol" charset="0"/>
+                      <a:endParaRPr lang="en-US" sz="1400" dirty="0">
+                        <a:latin typeface="Calibri" charset="0"/>
+                        <a:ea typeface="Calibri" charset="0"/>
+                        <a:cs typeface="Calibri" charset="0"/>
                       </a:endParaRPr>
                     </a:p>
                   </a:txBody>
-                  <a:tcPr marL="0" marR="0" marT="0" marB="0" anchor="ctr">
-                    <a:lnL w="12700" cap="flat" cmpd="sng" algn="ctr">
-                      <a:solidFill>
-                        <a:srgbClr val="B1BBC8"/>
-                      </a:solidFill>
-                      <a:prstDash val="solid"/>
-                      <a:round/>
-                      <a:headEnd type="none" w="med" len="med"/>
-                      <a:tailEnd type="none" w="med" len="med"/>
-                    </a:lnL>
-                    <a:lnR w="12700" cap="flat" cmpd="sng" algn="ctr">
-                      <a:solidFill>
-                        <a:srgbClr val="B1BBC8"/>
-                      </a:solidFill>
-                      <a:prstDash val="solid"/>
-                      <a:round/>
-                      <a:headEnd type="none" w="med" len="med"/>
-                      <a:tailEnd type="none" w="med" len="med"/>
-                    </a:lnR>
-                    <a:lnT w="12700" cap="flat" cmpd="sng" algn="ctr">
-                      <a:solidFill>
-                        <a:srgbClr val="B1BBC8"/>
-                      </a:solidFill>
-                      <a:prstDash val="solid"/>
-                      <a:round/>
-                      <a:headEnd type="none" w="med" len="med"/>
-                      <a:tailEnd type="none" w="med" len="med"/>
-                    </a:lnT>
-                    <a:lnB w="12700" cap="flat" cmpd="sng" algn="ctr">
-                      <a:solidFill>
-                        <a:srgbClr val="B1BBC8"/>
-                      </a:solidFill>
-                      <a:prstDash val="solid"/>
-                      <a:round/>
-                      <a:headEnd type="none" w="med" len="med"/>
-                      <a:tailEnd type="none" w="med" len="med"/>
-                    </a:lnB>
-                    <a:solidFill>
-                      <a:srgbClr val="FFFFFF"/>
-                    </a:solidFill>
-                  </a:tcPr>
-                </a:tc>
-                <a:tc>
-                  <a:txBody>
-                    <a:bodyPr/>
-                    <a:lstStyle/>
-                    <a:p>
-                      <a:pPr algn="ctr" indent="0" marL="0">
-                        <a:buNone/>
-                      </a:pPr>
-                      <a:r>
-                        <a:rPr lang="en-US" sz="1900" dirty="0">
-                          <a:solidFill>
-                            <a:srgbClr val="B23B3B"/>
-                          </a:solidFill>
-                          <a:latin typeface="Segoe UI Symbol" pitchFamily="34" charset="0"/>
-                          <a:ea typeface="Segoe UI Symbol" pitchFamily="34" charset="-122"/>
-                          <a:cs typeface="Segoe UI Symbol" pitchFamily="34" charset="-120"/>
-                        </a:rPr>
-                        <a:t>✗</a:t>
-                      </a:r>
-                      <a:endParaRPr lang="en-US" sz="1900" dirty="0">
-                        <a:latin typeface="Segoe UI Symbol" charset="0"/>
-                        <a:ea typeface="Segoe UI Symbol" charset="0"/>
-                        <a:cs typeface="Segoe UI Symbol" charset="0"/>
-                      </a:endParaRPr>
-                    </a:p>
-                  </a:txBody>
-                  <a:tcPr marL="0" marR="0" marT="0" marB="0" anchor="ctr">
-                    <a:lnL w="12700" cap="flat" cmpd="sng" algn="ctr">
-                      <a:solidFill>
-                        <a:srgbClr val="B1BBC8"/>
-                      </a:solidFill>
-                      <a:prstDash val="solid"/>
-                      <a:round/>
-                      <a:headEnd type="none" w="med" len="med"/>
-                      <a:tailEnd type="none" w="med" len="med"/>
-                    </a:lnL>
-                    <a:lnR w="12700" cap="flat" cmpd="sng" algn="ctr">
-                      <a:solidFill>
-                        <a:srgbClr val="B1BBC8"/>
-                      </a:solidFill>
-                      <a:prstDash val="solid"/>
-                      <a:round/>
-                      <a:headEnd type="none" w="med" len="med"/>
-                      <a:tailEnd type="none" w="med" len="med"/>
-                    </a:lnR>
-                    <a:lnT w="12700" cap="flat" cmpd="sng" algn="ctr">
-                      <a:solidFill>
-                        <a:srgbClr val="B1BBC8"/>
-                      </a:solidFill>
-                      <a:prstDash val="solid"/>
-                      <a:round/>
-                      <a:headEnd type="none" w="med" len="med"/>
-                      <a:tailEnd type="none" w="med" len="med"/>
-                    </a:lnT>
-                    <a:lnB w="12700" cap="flat" cmpd="sng" algn="ctr">
-                      <a:solidFill>
-                        <a:srgbClr val="B1BBC8"/>
-                      </a:solidFill>
-                      <a:prstDash val="solid"/>
-                      <a:round/>
-                      <a:headEnd type="none" w="med" len="med"/>
-                      <a:tailEnd type="none" w="med" len="med"/>
-                    </a:lnB>
-                    <a:solidFill>
-                      <a:srgbClr val="FFFFFF"/>
-                    </a:solidFill>
-                  </a:tcPr>
-                </a:tc>
-                <a:tc>
-                  <a:txBody>
-                    <a:bodyPr/>
-                    <a:lstStyle/>
-                    <a:p>
-                      <a:pPr algn="ctr" indent="0" marL="0">
-                        <a:buNone/>
-                      </a:pPr>
-                      <a:r>
-                        <a:rPr lang="en-US" sz="1900" dirty="0">
-                          <a:solidFill>
-                            <a:srgbClr val="B23B3B"/>
-                          </a:solidFill>
-                          <a:latin typeface="Segoe UI Symbol" pitchFamily="34" charset="0"/>
-                          <a:ea typeface="Segoe UI Symbol" pitchFamily="34" charset="-122"/>
-                          <a:cs typeface="Segoe UI Symbol" pitchFamily="34" charset="-120"/>
-                        </a:rPr>
-                        <a:t>✗</a:t>
-                      </a:r>
-                      <a:endParaRPr lang="en-US" sz="1900" dirty="0">
-                        <a:latin typeface="Segoe UI Symbol" charset="0"/>
-                        <a:ea typeface="Segoe UI Symbol" charset="0"/>
-                        <a:cs typeface="Segoe UI Symbol" charset="0"/>
-                      </a:endParaRPr>
-                    </a:p>
-                  </a:txBody>
-                  <a:tcPr marL="0" marR="0" marT="0" marB="0" anchor="ctr">
+                  <a:tcPr marL="101600" marR="76200" marT="0" marB="0" anchor="ctr">
                     <a:lnL w="12700" cap="flat" cmpd="sng" algn="ctr">
                       <a:solidFill>
                         <a:srgbClr val="B1BBC8"/>
@@ -16025,28 +15751,28 @@
                     <a:bodyPr/>
                     <a:lstStyle/>
                     <a:p>
-                      <a:pPr algn="ctr" indent="0" marL="0">
+                      <a:pPr indent="0" marL="0">
                         <a:buNone/>
                       </a:pPr>
                       <a:r>
-                        <a:rPr lang="en-US" sz="1900" dirty="0">
+                        <a:rPr lang="en-US" sz="1450" dirty="0">
                           <a:solidFill>
-                            <a:srgbClr val="2E7D4F"/>
+                            <a:srgbClr val="1A2F57"/>
                           </a:solidFill>
-                          <a:latin typeface="Segoe UI Symbol" pitchFamily="34" charset="0"/>
-                          <a:ea typeface="Segoe UI Symbol" pitchFamily="34" charset="-122"/>
-                          <a:cs typeface="Segoe UI Symbol" pitchFamily="34" charset="-120"/>
+                          <a:latin typeface="Calibri" pitchFamily="34" charset="0"/>
+                          <a:ea typeface="Calibri" pitchFamily="34" charset="-122"/>
+                          <a:cs typeface="Calibri" pitchFamily="34" charset="-120"/>
                         </a:rPr>
-                        <a:t>✓</a:t>
+                        <a:t>Same-site and bulk-order patterns, meaning match</a:t>
                       </a:r>
-                      <a:endParaRPr lang="en-US" sz="1900" dirty="0">
-                        <a:latin typeface="Segoe UI Symbol" charset="0"/>
-                        <a:ea typeface="Segoe UI Symbol" charset="0"/>
-                        <a:cs typeface="Segoe UI Symbol" charset="0"/>
+                      <a:endParaRPr lang="en-US" sz="1450" dirty="0">
+                        <a:latin typeface="Calibri" charset="0"/>
+                        <a:ea typeface="Calibri" charset="0"/>
+                        <a:cs typeface="Calibri" charset="0"/>
                       </a:endParaRPr>
                     </a:p>
                   </a:txBody>
-                  <a:tcPr marL="0" marR="0" marT="0" marB="0" anchor="ctr">
+                  <a:tcPr marL="101600" marR="76200" marT="0" marB="0" anchor="ctr">
                     <a:lnL w="12700" cap="flat" cmpd="sng" algn="ctr">
                       <a:solidFill>
                         <a:srgbClr val="B1BBC8"/>
@@ -16093,28 +15819,28 @@
                     <a:bodyPr/>
                     <a:lstStyle/>
                     <a:p>
-                      <a:pPr algn="ctr" indent="0" marL="0">
+                      <a:pPr indent="0" marL="0">
                         <a:buNone/>
                       </a:pPr>
                       <a:r>
-                        <a:rPr lang="en-US" sz="1900" dirty="0">
+                        <a:rPr lang="en-US" sz="1400" b="1" dirty="0">
                           <a:solidFill>
-                            <a:srgbClr val="B23B3B"/>
+                            <a:srgbClr val="2A4D88"/>
                           </a:solidFill>
-                          <a:latin typeface="Segoe UI Symbol" pitchFamily="34" charset="0"/>
-                          <a:ea typeface="Segoe UI Symbol" pitchFamily="34" charset="-122"/>
-                          <a:cs typeface="Segoe UI Symbol" pitchFamily="34" charset="-120"/>
+                          <a:latin typeface="Calibri" pitchFamily="34" charset="0"/>
+                          <a:ea typeface="Calibri" pitchFamily="34" charset="-122"/>
+                          <a:cs typeface="Calibri" pitchFamily="34" charset="-120"/>
                         </a:rPr>
-                        <a:t>✗</a:t>
+                        <a:t>Before sanction</a:t>
                       </a:r>
-                      <a:endParaRPr lang="en-US" sz="1900" dirty="0">
-                        <a:latin typeface="Segoe UI Symbol" charset="0"/>
-                        <a:ea typeface="Segoe UI Symbol" charset="0"/>
-                        <a:cs typeface="Segoe UI Symbol" charset="0"/>
+                      <a:endParaRPr lang="en-US" sz="1400" dirty="0">
+                        <a:latin typeface="Calibri" charset="0"/>
+                        <a:ea typeface="Calibri" charset="0"/>
+                        <a:cs typeface="Calibri" charset="0"/>
                       </a:endParaRPr>
                     </a:p>
                   </a:txBody>
-                  <a:tcPr marL="0" marR="0" marT="0" marB="0" anchor="ctr">
+                  <a:tcPr marL="101600" marR="76200" marT="0" marB="0" anchor="ctr">
                     <a:lnL w="12700" cap="flat" cmpd="sng" algn="ctr">
                       <a:solidFill>
                         <a:srgbClr val="B1BBC8"/>
@@ -16153,6 +15879,76 @@
                     </a:lnB>
                     <a:solidFill>
                       <a:srgbClr val="FFFFFF"/>
+                    </a:solidFill>
+                  </a:tcPr>
+                </a:tc>
+              </a:tr>
+              <a:tr h="419100">
+                <a:tc>
+                  <a:txBody>
+                    <a:bodyPr/>
+                    <a:lstStyle/>
+                    <a:p>
+                      <a:pPr indent="0" marL="0">
+                        <a:buNone/>
+                      </a:pPr>
+                      <a:r>
+                        <a:rPr lang="en-US" sz="1450" b="1" dirty="0">
+                          <a:solidFill>
+                            <a:srgbClr val="1A2F57"/>
+                          </a:solidFill>
+                          <a:latin typeface="Calibri" pitchFamily="34" charset="0"/>
+                          <a:ea typeface="Calibri" pitchFamily="34" charset="-122"/>
+                          <a:cs typeface="Calibri" pitchFamily="34" charset="-120"/>
+                        </a:rPr>
+                        <a:t>Guideline compliance with para cited</a:t>
+                      </a:r>
+                      <a:endParaRPr lang="en-US" sz="1450" dirty="0">
+                        <a:latin typeface="Calibri" charset="0"/>
+                        <a:ea typeface="Calibri" charset="0"/>
+                        <a:cs typeface="Calibri" charset="0"/>
+                      </a:endParaRPr>
+                    </a:p>
+                  </a:txBody>
+                  <a:tcPr marL="76200" marR="76200" marT="0" marB="0" anchor="ctr">
+                    <a:lnL w="12700" cap="flat" cmpd="sng" algn="ctr">
+                      <a:solidFill>
+                        <a:srgbClr val="B1BBC8"/>
+                      </a:solidFill>
+                      <a:prstDash val="solid"/>
+                      <a:round/>
+                      <a:headEnd type="none" w="med" len="med"/>
+                      <a:tailEnd type="none" w="med" len="med"/>
+                    </a:lnL>
+                    <a:lnR w="12700" cap="flat" cmpd="sng" algn="ctr">
+                      <a:solidFill>
+                        <a:srgbClr val="B1BBC8"/>
+                      </a:solidFill>
+                      <a:prstDash val="solid"/>
+                      <a:round/>
+                      <a:headEnd type="none" w="med" len="med"/>
+                      <a:tailEnd type="none" w="med" len="med"/>
+                    </a:lnR>
+                    <a:lnT w="12700" cap="flat" cmpd="sng" algn="ctr">
+                      <a:solidFill>
+                        <a:srgbClr val="B1BBC8"/>
+                      </a:solidFill>
+                      <a:prstDash val="solid"/>
+                      <a:round/>
+                      <a:headEnd type="none" w="med" len="med"/>
+                      <a:tailEnd type="none" w="med" len="med"/>
+                    </a:lnT>
+                    <a:lnB w="12700" cap="flat" cmpd="sng" algn="ctr">
+                      <a:solidFill>
+                        <a:srgbClr val="B1BBC8"/>
+                      </a:solidFill>
+                      <a:prstDash val="solid"/>
+                      <a:round/>
+                      <a:headEnd type="none" w="med" len="med"/>
+                      <a:tailEnd type="none" w="med" len="med"/>
+                    </a:lnB>
+                    <a:solidFill>
+                      <a:srgbClr val="EDF0F5"/>
                     </a:solidFill>
                   </a:tcPr>
                 </a:tc>
@@ -16161,19 +15957,19 @@
                     <a:bodyPr/>
                     <a:lstStyle/>
                     <a:p>
-                      <a:pPr algn="ctr" indent="0" marL="0">
+                      <a:pPr indent="0" marL="0">
                         <a:buNone/>
                       </a:pPr>
                       <a:r>
-                        <a:rPr lang="en-US" sz="1450" b="1" dirty="0">
+                        <a:rPr lang="en-US" sz="1450" dirty="0">
                           <a:solidFill>
-                            <a:srgbClr val="8A6D1F"/>
+                            <a:srgbClr val="1A2F57"/>
                           </a:solidFill>
                           <a:latin typeface="Calibri" pitchFamily="34" charset="0"/>
                           <a:ea typeface="Calibri" pitchFamily="34" charset="-122"/>
                           <a:cs typeface="Calibri" pitchFamily="34" charset="-120"/>
                         </a:rPr>
-                        <a:t>Partial</a:t>
+                        <a:t>Rules + the clause quoted on every flag</a:t>
                       </a:r>
                       <a:endParaRPr lang="en-US" sz="1450" dirty="0">
                         <a:latin typeface="Calibri" charset="0"/>
@@ -16182,7 +15978,7 @@
                       </a:endParaRPr>
                     </a:p>
                   </a:txBody>
-                  <a:tcPr marL="0" marR="0" marT="0" marB="0" anchor="ctr">
+                  <a:tcPr marL="101600" marR="76200" marT="0" marB="0" anchor="ctr">
                     <a:lnL w="12700" cap="flat" cmpd="sng" algn="ctr">
                       <a:solidFill>
                         <a:srgbClr val="B1BBC8"/>
@@ -16220,7 +16016,7 @@
                       <a:tailEnd type="none" w="med" len="med"/>
                     </a:lnB>
                     <a:solidFill>
-                      <a:srgbClr val="FFFFFF"/>
+                      <a:srgbClr val="FBF3E6"/>
                     </a:solidFill>
                   </a:tcPr>
                 </a:tc>
@@ -16229,28 +16025,28 @@
                     <a:bodyPr/>
                     <a:lstStyle/>
                     <a:p>
-                      <a:pPr algn="ctr" indent="0" marL="0">
+                      <a:pPr indent="0" marL="0">
                         <a:buNone/>
                       </a:pPr>
                       <a:r>
-                        <a:rPr lang="en-US" sz="1900" dirty="0">
+                        <a:rPr lang="en-US" sz="1400" b="1" dirty="0">
                           <a:solidFill>
-                            <a:srgbClr val="B23B3B"/>
+                            <a:srgbClr val="2A4D88"/>
                           </a:solidFill>
-                          <a:latin typeface="Segoe UI Symbol" pitchFamily="34" charset="0"/>
-                          <a:ea typeface="Segoe UI Symbol" pitchFamily="34" charset="-122"/>
-                          <a:cs typeface="Segoe UI Symbol" pitchFamily="34" charset="-120"/>
+                          <a:latin typeface="Calibri" pitchFamily="34" charset="0"/>
+                          <a:ea typeface="Calibri" pitchFamily="34" charset="-122"/>
+                          <a:cs typeface="Calibri" pitchFamily="34" charset="-120"/>
                         </a:rPr>
-                        <a:t>✗</a:t>
+                        <a:t>Before sanction</a:t>
                       </a:r>
-                      <a:endParaRPr lang="en-US" sz="1900" dirty="0">
-                        <a:latin typeface="Segoe UI Symbol" charset="0"/>
-                        <a:ea typeface="Segoe UI Symbol" charset="0"/>
-                        <a:cs typeface="Segoe UI Symbol" charset="0"/>
+                      <a:endParaRPr lang="en-US" sz="1400" dirty="0">
+                        <a:latin typeface="Calibri" charset="0"/>
+                        <a:ea typeface="Calibri" charset="0"/>
+                        <a:cs typeface="Calibri" charset="0"/>
                       </a:endParaRPr>
                     </a:p>
                   </a:txBody>
-                  <a:tcPr marL="0" marR="0" marT="0" marB="0" anchor="ctr">
+                  <a:tcPr marL="101600" marR="76200" marT="0" marB="0" anchor="ctr">
                     <a:lnL w="12700" cap="flat" cmpd="sng" algn="ctr">
                       <a:solidFill>
                         <a:srgbClr val="B1BBC8"/>
@@ -16367,28 +16163,28 @@
                     <a:bodyPr/>
                     <a:lstStyle/>
                     <a:p>
-                      <a:pPr algn="ctr" indent="0" marL="0">
+                      <a:pPr indent="0" marL="0">
                         <a:buNone/>
                       </a:pPr>
                       <a:r>
-                        <a:rPr lang="en-US" sz="1900" dirty="0">
+                        <a:rPr lang="en-US" sz="1450" dirty="0">
                           <a:solidFill>
-                            <a:srgbClr val="2E7D4F"/>
+                            <a:srgbClr val="1A2F57"/>
                           </a:solidFill>
-                          <a:latin typeface="Segoe UI Symbol" pitchFamily="34" charset="0"/>
-                          <a:ea typeface="Segoe UI Symbol" pitchFamily="34" charset="-122"/>
-                          <a:cs typeface="Segoe UI Symbol" pitchFamily="34" charset="-120"/>
+                          <a:latin typeface="Calibri" pitchFamily="34" charset="0"/>
+                          <a:ea typeface="Calibri" pitchFamily="34" charset="-122"/>
+                          <a:cs typeface="Calibri" pitchFamily="34" charset="-120"/>
                         </a:rPr>
-                        <a:t>✓</a:t>
+                        <a:t>Sanction date, payments and contractor read</a:t>
                       </a:r>
-                      <a:endParaRPr lang="en-US" sz="1900" dirty="0">
-                        <a:latin typeface="Segoe UI Symbol" charset="0"/>
-                        <a:ea typeface="Segoe UI Symbol" charset="0"/>
-                        <a:cs typeface="Segoe UI Symbol" charset="0"/>
+                      <a:endParaRPr lang="en-US" sz="1450" dirty="0">
+                        <a:latin typeface="Calibri" charset="0"/>
+                        <a:ea typeface="Calibri" charset="0"/>
+                        <a:cs typeface="Calibri" charset="0"/>
                       </a:endParaRPr>
                     </a:p>
                   </a:txBody>
-                  <a:tcPr marL="0" marR="0" marT="0" marB="0" anchor="ctr">
+                  <a:tcPr marL="101600" marR="76200" marT="0" marB="0" anchor="ctr">
                     <a:lnL w="12700" cap="flat" cmpd="sng" algn="ctr">
                       <a:solidFill>
                         <a:srgbClr val="B1BBC8"/>
@@ -16435,164 +16231,28 @@
                     <a:bodyPr/>
                     <a:lstStyle/>
                     <a:p>
-                      <a:pPr algn="ctr" indent="0" marL="0">
+                      <a:pPr indent="0" marL="0">
                         <a:buNone/>
                       </a:pPr>
                       <a:r>
-                        <a:rPr lang="en-US" sz="1900" dirty="0">
+                        <a:rPr lang="en-US" sz="1400" b="1" dirty="0">
                           <a:solidFill>
-                            <a:srgbClr val="B23B3B"/>
-                          </a:solidFill>
-                          <a:latin typeface="Segoe UI Symbol" pitchFamily="34" charset="0"/>
-                          <a:ea typeface="Segoe UI Symbol" pitchFamily="34" charset="-122"/>
-                          <a:cs typeface="Segoe UI Symbol" pitchFamily="34" charset="-120"/>
-                        </a:rPr>
-                        <a:t>✗</a:t>
-                      </a:r>
-                      <a:endParaRPr lang="en-US" sz="1900" dirty="0">
-                        <a:latin typeface="Segoe UI Symbol" charset="0"/>
-                        <a:ea typeface="Segoe UI Symbol" charset="0"/>
-                        <a:cs typeface="Segoe UI Symbol" charset="0"/>
-                      </a:endParaRPr>
-                    </a:p>
-                  </a:txBody>
-                  <a:tcPr marL="0" marR="0" marT="0" marB="0" anchor="ctr">
-                    <a:lnL w="12700" cap="flat" cmpd="sng" algn="ctr">
-                      <a:solidFill>
-                        <a:srgbClr val="B1BBC8"/>
-                      </a:solidFill>
-                      <a:prstDash val="solid"/>
-                      <a:round/>
-                      <a:headEnd type="none" w="med" len="med"/>
-                      <a:tailEnd type="none" w="med" len="med"/>
-                    </a:lnL>
-                    <a:lnR w="12700" cap="flat" cmpd="sng" algn="ctr">
-                      <a:solidFill>
-                        <a:srgbClr val="B1BBC8"/>
-                      </a:solidFill>
-                      <a:prstDash val="solid"/>
-                      <a:round/>
-                      <a:headEnd type="none" w="med" len="med"/>
-                      <a:tailEnd type="none" w="med" len="med"/>
-                    </a:lnR>
-                    <a:lnT w="12700" cap="flat" cmpd="sng" algn="ctr">
-                      <a:solidFill>
-                        <a:srgbClr val="B1BBC8"/>
-                      </a:solidFill>
-                      <a:prstDash val="solid"/>
-                      <a:round/>
-                      <a:headEnd type="none" w="med" len="med"/>
-                      <a:tailEnd type="none" w="med" len="med"/>
-                    </a:lnT>
-                    <a:lnB w="12700" cap="flat" cmpd="sng" algn="ctr">
-                      <a:solidFill>
-                        <a:srgbClr val="B1BBC8"/>
-                      </a:solidFill>
-                      <a:prstDash val="solid"/>
-                      <a:round/>
-                      <a:headEnd type="none" w="med" len="med"/>
-                      <a:tailEnd type="none" w="med" len="med"/>
-                    </a:lnB>
-                    <a:solidFill>
-                      <a:srgbClr val="FFFFFF"/>
-                    </a:solidFill>
-                  </a:tcPr>
-                </a:tc>
-                <a:tc>
-                  <a:txBody>
-                    <a:bodyPr/>
-                    <a:lstStyle/>
-                    <a:p>
-                      <a:pPr algn="ctr" indent="0" marL="0">
-                        <a:buNone/>
-                      </a:pPr>
-                      <a:r>
-                        <a:rPr lang="en-US" sz="1450" b="1" dirty="0">
-                          <a:solidFill>
-                            <a:srgbClr val="8A6D1F"/>
+                            <a:srgbClr val="2A4D88"/>
                           </a:solidFill>
                           <a:latin typeface="Calibri" pitchFamily="34" charset="0"/>
                           <a:ea typeface="Calibri" pitchFamily="34" charset="-122"/>
                           <a:cs typeface="Calibri" pitchFamily="34" charset="-120"/>
                         </a:rPr>
-                        <a:t>Partial</a:t>
+                        <a:t>During work</a:t>
                       </a:r>
-                      <a:endParaRPr lang="en-US" sz="1450" dirty="0">
+                      <a:endParaRPr lang="en-US" sz="1400" dirty="0">
                         <a:latin typeface="Calibri" charset="0"/>
                         <a:ea typeface="Calibri" charset="0"/>
                         <a:cs typeface="Calibri" charset="0"/>
                       </a:endParaRPr>
                     </a:p>
                   </a:txBody>
-                  <a:tcPr marL="0" marR="0" marT="0" marB="0" anchor="ctr">
-                    <a:lnL w="12700" cap="flat" cmpd="sng" algn="ctr">
-                      <a:solidFill>
-                        <a:srgbClr val="B1BBC8"/>
-                      </a:solidFill>
-                      <a:prstDash val="solid"/>
-                      <a:round/>
-                      <a:headEnd type="none" w="med" len="med"/>
-                      <a:tailEnd type="none" w="med" len="med"/>
-                    </a:lnL>
-                    <a:lnR w="12700" cap="flat" cmpd="sng" algn="ctr">
-                      <a:solidFill>
-                        <a:srgbClr val="B1BBC8"/>
-                      </a:solidFill>
-                      <a:prstDash val="solid"/>
-                      <a:round/>
-                      <a:headEnd type="none" w="med" len="med"/>
-                      <a:tailEnd type="none" w="med" len="med"/>
-                    </a:lnR>
-                    <a:lnT w="12700" cap="flat" cmpd="sng" algn="ctr">
-                      <a:solidFill>
-                        <a:srgbClr val="B1BBC8"/>
-                      </a:solidFill>
-                      <a:prstDash val="solid"/>
-                      <a:round/>
-                      <a:headEnd type="none" w="med" len="med"/>
-                      <a:tailEnd type="none" w="med" len="med"/>
-                    </a:lnT>
-                    <a:lnB w="12700" cap="flat" cmpd="sng" algn="ctr">
-                      <a:solidFill>
-                        <a:srgbClr val="B1BBC8"/>
-                      </a:solidFill>
-                      <a:prstDash val="solid"/>
-                      <a:round/>
-                      <a:headEnd type="none" w="med" len="med"/>
-                      <a:tailEnd type="none" w="med" len="med"/>
-                    </a:lnB>
-                    <a:solidFill>
-                      <a:srgbClr val="FFFFFF"/>
-                    </a:solidFill>
-                  </a:tcPr>
-                </a:tc>
-                <a:tc>
-                  <a:txBody>
-                    <a:bodyPr/>
-                    <a:lstStyle/>
-                    <a:p>
-                      <a:pPr algn="ctr" indent="0" marL="0">
-                        <a:buNone/>
-                      </a:pPr>
-                      <a:r>
-                        <a:rPr lang="en-US" sz="1900" dirty="0">
-                          <a:solidFill>
-                            <a:srgbClr val="B23B3B"/>
-                          </a:solidFill>
-                          <a:latin typeface="Segoe UI Symbol" pitchFamily="34" charset="0"/>
-                          <a:ea typeface="Segoe UI Symbol" pitchFamily="34" charset="-122"/>
-                          <a:cs typeface="Segoe UI Symbol" pitchFamily="34" charset="-120"/>
-                        </a:rPr>
-                        <a:t>✗</a:t>
-                      </a:r>
-                      <a:endParaRPr lang="en-US" sz="1900" dirty="0">
-                        <a:latin typeface="Segoe UI Symbol" charset="0"/>
-                        <a:ea typeface="Segoe UI Symbol" charset="0"/>
-                        <a:cs typeface="Segoe UI Symbol" charset="0"/>
-                      </a:endParaRPr>
-                    </a:p>
-                  </a:txBody>
-                  <a:tcPr marL="0" marR="0" marT="0" marB="0" anchor="ctr">
+                  <a:tcPr marL="101600" marR="76200" marT="0" marB="0" anchor="ctr">
                     <a:lnL w="12700" cap="flat" cmpd="sng" algn="ctr">
                       <a:solidFill>
                         <a:srgbClr val="B1BBC8"/>
@@ -16709,28 +16369,28 @@
                     <a:bodyPr/>
                     <a:lstStyle/>
                     <a:p>
-                      <a:pPr algn="ctr" indent="0" marL="0">
+                      <a:pPr indent="0" marL="0">
                         <a:buNone/>
                       </a:pPr>
                       <a:r>
-                        <a:rPr lang="en-US" sz="1900" dirty="0">
+                        <a:rPr lang="en-US" sz="1450" dirty="0">
                           <a:solidFill>
-                            <a:srgbClr val="2E7D4F"/>
+                            <a:srgbClr val="1A2F57"/>
                           </a:solidFill>
-                          <a:latin typeface="Segoe UI Symbol" pitchFamily="34" charset="0"/>
-                          <a:ea typeface="Segoe UI Symbol" pitchFamily="34" charset="-122"/>
-                          <a:cs typeface="Segoe UI Symbol" pitchFamily="34" charset="-120"/>
+                          <a:latin typeface="Calibri" pitchFamily="34" charset="0"/>
+                          <a:ea typeface="Calibri" pitchFamily="34" charset="-122"/>
+                          <a:cs typeface="Calibri" pitchFamily="34" charset="-120"/>
                         </a:rPr>
-                        <a:t>✓</a:t>
+                        <a:t>Image fingerprints + feature matching</a:t>
                       </a:r>
-                      <a:endParaRPr lang="en-US" sz="1900" dirty="0">
-                        <a:latin typeface="Segoe UI Symbol" charset="0"/>
-                        <a:ea typeface="Segoe UI Symbol" charset="0"/>
-                        <a:cs typeface="Segoe UI Symbol" charset="0"/>
+                      <a:endParaRPr lang="en-US" sz="1450" dirty="0">
+                        <a:latin typeface="Calibri" charset="0"/>
+                        <a:ea typeface="Calibri" charset="0"/>
+                        <a:cs typeface="Calibri" charset="0"/>
                       </a:endParaRPr>
                     </a:p>
                   </a:txBody>
-                  <a:tcPr marL="0" marR="0" marT="0" marB="0" anchor="ctr">
+                  <a:tcPr marL="101600" marR="76200" marT="0" marB="0" anchor="ctr">
                     <a:lnL w="12700" cap="flat" cmpd="sng" algn="ctr">
                       <a:solidFill>
                         <a:srgbClr val="B1BBC8"/>
@@ -16777,164 +16437,28 @@
                     <a:bodyPr/>
                     <a:lstStyle/>
                     <a:p>
-                      <a:pPr algn="ctr" indent="0" marL="0">
+                      <a:pPr indent="0" marL="0">
                         <a:buNone/>
                       </a:pPr>
                       <a:r>
-                        <a:rPr lang="en-US" sz="1900" dirty="0">
+                        <a:rPr lang="en-US" sz="1400" b="1" dirty="0">
                           <a:solidFill>
-                            <a:srgbClr val="B23B3B"/>
+                            <a:srgbClr val="2A4D88"/>
                           </a:solidFill>
-                          <a:latin typeface="Segoe UI Symbol" pitchFamily="34" charset="0"/>
-                          <a:ea typeface="Segoe UI Symbol" pitchFamily="34" charset="-122"/>
-                          <a:cs typeface="Segoe UI Symbol" pitchFamily="34" charset="-120"/>
+                          <a:latin typeface="Calibri" pitchFamily="34" charset="0"/>
+                          <a:ea typeface="Calibri" pitchFamily="34" charset="-122"/>
+                          <a:cs typeface="Calibri" pitchFamily="34" charset="-120"/>
                         </a:rPr>
-                        <a:t>✗</a:t>
+                        <a:t>During work</a:t>
                       </a:r>
-                      <a:endParaRPr lang="en-US" sz="1900" dirty="0">
-                        <a:latin typeface="Segoe UI Symbol" charset="0"/>
-                        <a:ea typeface="Segoe UI Symbol" charset="0"/>
-                        <a:cs typeface="Segoe UI Symbol" charset="0"/>
+                      <a:endParaRPr lang="en-US" sz="1400" dirty="0">
+                        <a:latin typeface="Calibri" charset="0"/>
+                        <a:ea typeface="Calibri" charset="0"/>
+                        <a:cs typeface="Calibri" charset="0"/>
                       </a:endParaRPr>
                     </a:p>
                   </a:txBody>
-                  <a:tcPr marL="0" marR="0" marT="0" marB="0" anchor="ctr">
-                    <a:lnL w="12700" cap="flat" cmpd="sng" algn="ctr">
-                      <a:solidFill>
-                        <a:srgbClr val="B1BBC8"/>
-                      </a:solidFill>
-                      <a:prstDash val="solid"/>
-                      <a:round/>
-                      <a:headEnd type="none" w="med" len="med"/>
-                      <a:tailEnd type="none" w="med" len="med"/>
-                    </a:lnL>
-                    <a:lnR w="12700" cap="flat" cmpd="sng" algn="ctr">
-                      <a:solidFill>
-                        <a:srgbClr val="B1BBC8"/>
-                      </a:solidFill>
-                      <a:prstDash val="solid"/>
-                      <a:round/>
-                      <a:headEnd type="none" w="med" len="med"/>
-                      <a:tailEnd type="none" w="med" len="med"/>
-                    </a:lnR>
-                    <a:lnT w="12700" cap="flat" cmpd="sng" algn="ctr">
-                      <a:solidFill>
-                        <a:srgbClr val="B1BBC8"/>
-                      </a:solidFill>
-                      <a:prstDash val="solid"/>
-                      <a:round/>
-                      <a:headEnd type="none" w="med" len="med"/>
-                      <a:tailEnd type="none" w="med" len="med"/>
-                    </a:lnT>
-                    <a:lnB w="12700" cap="flat" cmpd="sng" algn="ctr">
-                      <a:solidFill>
-                        <a:srgbClr val="B1BBC8"/>
-                      </a:solidFill>
-                      <a:prstDash val="solid"/>
-                      <a:round/>
-                      <a:headEnd type="none" w="med" len="med"/>
-                      <a:tailEnd type="none" w="med" len="med"/>
-                    </a:lnB>
-                    <a:solidFill>
-                      <a:srgbClr val="FFFFFF"/>
-                    </a:solidFill>
-                  </a:tcPr>
-                </a:tc>
-                <a:tc>
-                  <a:txBody>
-                    <a:bodyPr/>
-                    <a:lstStyle/>
-                    <a:p>
-                      <a:pPr algn="ctr" indent="0" marL="0">
-                        <a:buNone/>
-                      </a:pPr>
-                      <a:r>
-                        <a:rPr lang="en-US" sz="1900" dirty="0">
-                          <a:solidFill>
-                            <a:srgbClr val="B23B3B"/>
-                          </a:solidFill>
-                          <a:latin typeface="Segoe UI Symbol" pitchFamily="34" charset="0"/>
-                          <a:ea typeface="Segoe UI Symbol" pitchFamily="34" charset="-122"/>
-                          <a:cs typeface="Segoe UI Symbol" pitchFamily="34" charset="-120"/>
-                        </a:rPr>
-                        <a:t>✗</a:t>
-                      </a:r>
-                      <a:endParaRPr lang="en-US" sz="1900" dirty="0">
-                        <a:latin typeface="Segoe UI Symbol" charset="0"/>
-                        <a:ea typeface="Segoe UI Symbol" charset="0"/>
-                        <a:cs typeface="Segoe UI Symbol" charset="0"/>
-                      </a:endParaRPr>
-                    </a:p>
-                  </a:txBody>
-                  <a:tcPr marL="0" marR="0" marT="0" marB="0" anchor="ctr">
-                    <a:lnL w="12700" cap="flat" cmpd="sng" algn="ctr">
-                      <a:solidFill>
-                        <a:srgbClr val="B1BBC8"/>
-                      </a:solidFill>
-                      <a:prstDash val="solid"/>
-                      <a:round/>
-                      <a:headEnd type="none" w="med" len="med"/>
-                      <a:tailEnd type="none" w="med" len="med"/>
-                    </a:lnL>
-                    <a:lnR w="12700" cap="flat" cmpd="sng" algn="ctr">
-                      <a:solidFill>
-                        <a:srgbClr val="B1BBC8"/>
-                      </a:solidFill>
-                      <a:prstDash val="solid"/>
-                      <a:round/>
-                      <a:headEnd type="none" w="med" len="med"/>
-                      <a:tailEnd type="none" w="med" len="med"/>
-                    </a:lnR>
-                    <a:lnT w="12700" cap="flat" cmpd="sng" algn="ctr">
-                      <a:solidFill>
-                        <a:srgbClr val="B1BBC8"/>
-                      </a:solidFill>
-                      <a:prstDash val="solid"/>
-                      <a:round/>
-                      <a:headEnd type="none" w="med" len="med"/>
-                      <a:tailEnd type="none" w="med" len="med"/>
-                    </a:lnT>
-                    <a:lnB w="12700" cap="flat" cmpd="sng" algn="ctr">
-                      <a:solidFill>
-                        <a:srgbClr val="B1BBC8"/>
-                      </a:solidFill>
-                      <a:prstDash val="solid"/>
-                      <a:round/>
-                      <a:headEnd type="none" w="med" len="med"/>
-                      <a:tailEnd type="none" w="med" len="med"/>
-                    </a:lnB>
-                    <a:solidFill>
-                      <a:srgbClr val="FFFFFF"/>
-                    </a:solidFill>
-                  </a:tcPr>
-                </a:tc>
-                <a:tc>
-                  <a:txBody>
-                    <a:bodyPr/>
-                    <a:lstStyle/>
-                    <a:p>
-                      <a:pPr algn="ctr" indent="0" marL="0">
-                        <a:buNone/>
-                      </a:pPr>
-                      <a:r>
-                        <a:rPr lang="en-US" sz="1900" dirty="0">
-                          <a:solidFill>
-                            <a:srgbClr val="B23B3B"/>
-                          </a:solidFill>
-                          <a:latin typeface="Segoe UI Symbol" pitchFamily="34" charset="0"/>
-                          <a:ea typeface="Segoe UI Symbol" pitchFamily="34" charset="-122"/>
-                          <a:cs typeface="Segoe UI Symbol" pitchFamily="34" charset="-120"/>
-                        </a:rPr>
-                        <a:t>✗</a:t>
-                      </a:r>
-                      <a:endParaRPr lang="en-US" sz="1900" dirty="0">
-                        <a:latin typeface="Segoe UI Symbol" charset="0"/>
-                        <a:ea typeface="Segoe UI Symbol" charset="0"/>
-                        <a:cs typeface="Segoe UI Symbol" charset="0"/>
-                      </a:endParaRPr>
-                    </a:p>
-                  </a:txBody>
-                  <a:tcPr marL="0" marR="0" marT="0" marB="0" anchor="ctr">
+                  <a:tcPr marL="101600" marR="76200" marT="0" marB="0" anchor="ctr">
                     <a:lnL w="12700" cap="flat" cmpd="sng" algn="ctr">
                       <a:solidFill>
                         <a:srgbClr val="B1BBC8"/>
@@ -17051,28 +16575,28 @@
                     <a:bodyPr/>
                     <a:lstStyle/>
                     <a:p>
-                      <a:pPr algn="ctr" indent="0" marL="0">
+                      <a:pPr indent="0" marL="0">
                         <a:buNone/>
                       </a:pPr>
                       <a:r>
-                        <a:rPr lang="en-US" sz="1900" dirty="0">
+                        <a:rPr lang="en-US" sz="1450" dirty="0">
                           <a:solidFill>
-                            <a:srgbClr val="2E7D4F"/>
+                            <a:srgbClr val="1A2F57"/>
                           </a:solidFill>
-                          <a:latin typeface="Segoe UI Symbol" pitchFamily="34" charset="0"/>
-                          <a:ea typeface="Segoe UI Symbol" pitchFamily="34" charset="-122"/>
-                          <a:cs typeface="Segoe UI Symbol" pitchFamily="34" charset="-120"/>
+                          <a:latin typeface="Calibri" pitchFamily="34" charset="0"/>
+                          <a:ea typeface="Calibri" pitchFamily="34" charset="-122"/>
+                          <a:cs typeface="Calibri" pitchFamily="34" charset="-120"/>
                         </a:rPr>
-                        <a:t>✓</a:t>
+                        <a:t>GPS stamp read; district, PIN and date checked</a:t>
                       </a:r>
-                      <a:endParaRPr lang="en-US" sz="1900" dirty="0">
-                        <a:latin typeface="Segoe UI Symbol" charset="0"/>
-                        <a:ea typeface="Segoe UI Symbol" charset="0"/>
-                        <a:cs typeface="Segoe UI Symbol" charset="0"/>
+                      <a:endParaRPr lang="en-US" sz="1450" dirty="0">
+                        <a:latin typeface="Calibri" charset="0"/>
+                        <a:ea typeface="Calibri" charset="0"/>
+                        <a:cs typeface="Calibri" charset="0"/>
                       </a:endParaRPr>
                     </a:p>
                   </a:txBody>
-                  <a:tcPr marL="0" marR="0" marT="0" marB="0" anchor="ctr">
+                  <a:tcPr marL="101600" marR="76200" marT="0" marB="0" anchor="ctr">
                     <a:lnL w="12700" cap="flat" cmpd="sng" algn="ctr">
                       <a:solidFill>
                         <a:srgbClr val="B1BBC8"/>
@@ -17119,164 +16643,28 @@
                     <a:bodyPr/>
                     <a:lstStyle/>
                     <a:p>
-                      <a:pPr algn="ctr" indent="0" marL="0">
+                      <a:pPr indent="0" marL="0">
                         <a:buNone/>
                       </a:pPr>
                       <a:r>
-                        <a:rPr lang="en-US" sz="1450" b="1" dirty="0">
+                        <a:rPr lang="en-US" sz="1400" b="1" dirty="0">
                           <a:solidFill>
-                            <a:srgbClr val="8A6D1F"/>
+                            <a:srgbClr val="2A4D88"/>
                           </a:solidFill>
                           <a:latin typeface="Calibri" pitchFamily="34" charset="0"/>
                           <a:ea typeface="Calibri" pitchFamily="34" charset="-122"/>
                           <a:cs typeface="Calibri" pitchFamily="34" charset="-120"/>
                         </a:rPr>
-                        <a:t>Partial</a:t>
+                        <a:t>During work</a:t>
                       </a:r>
-                      <a:endParaRPr lang="en-US" sz="1450" dirty="0">
+                      <a:endParaRPr lang="en-US" sz="1400" dirty="0">
                         <a:latin typeface="Calibri" charset="0"/>
                         <a:ea typeface="Calibri" charset="0"/>
                         <a:cs typeface="Calibri" charset="0"/>
                       </a:endParaRPr>
                     </a:p>
                   </a:txBody>
-                  <a:tcPr marL="0" marR="0" marT="0" marB="0" anchor="ctr">
-                    <a:lnL w="12700" cap="flat" cmpd="sng" algn="ctr">
-                      <a:solidFill>
-                        <a:srgbClr val="B1BBC8"/>
-                      </a:solidFill>
-                      <a:prstDash val="solid"/>
-                      <a:round/>
-                      <a:headEnd type="none" w="med" len="med"/>
-                      <a:tailEnd type="none" w="med" len="med"/>
-                    </a:lnL>
-                    <a:lnR w="12700" cap="flat" cmpd="sng" algn="ctr">
-                      <a:solidFill>
-                        <a:srgbClr val="B1BBC8"/>
-                      </a:solidFill>
-                      <a:prstDash val="solid"/>
-                      <a:round/>
-                      <a:headEnd type="none" w="med" len="med"/>
-                      <a:tailEnd type="none" w="med" len="med"/>
-                    </a:lnR>
-                    <a:lnT w="12700" cap="flat" cmpd="sng" algn="ctr">
-                      <a:solidFill>
-                        <a:srgbClr val="B1BBC8"/>
-                      </a:solidFill>
-                      <a:prstDash val="solid"/>
-                      <a:round/>
-                      <a:headEnd type="none" w="med" len="med"/>
-                      <a:tailEnd type="none" w="med" len="med"/>
-                    </a:lnT>
-                    <a:lnB w="12700" cap="flat" cmpd="sng" algn="ctr">
-                      <a:solidFill>
-                        <a:srgbClr val="B1BBC8"/>
-                      </a:solidFill>
-                      <a:prstDash val="solid"/>
-                      <a:round/>
-                      <a:headEnd type="none" w="med" len="med"/>
-                      <a:tailEnd type="none" w="med" len="med"/>
-                    </a:lnB>
-                    <a:solidFill>
-                      <a:srgbClr val="FFFFFF"/>
-                    </a:solidFill>
-                  </a:tcPr>
-                </a:tc>
-                <a:tc>
-                  <a:txBody>
-                    <a:bodyPr/>
-                    <a:lstStyle/>
-                    <a:p>
-                      <a:pPr algn="ctr" indent="0" marL="0">
-                        <a:buNone/>
-                      </a:pPr>
-                      <a:r>
-                        <a:rPr lang="en-US" sz="1900" dirty="0">
-                          <a:solidFill>
-                            <a:srgbClr val="B23B3B"/>
-                          </a:solidFill>
-                          <a:latin typeface="Segoe UI Symbol" pitchFamily="34" charset="0"/>
-                          <a:ea typeface="Segoe UI Symbol" pitchFamily="34" charset="-122"/>
-                          <a:cs typeface="Segoe UI Symbol" pitchFamily="34" charset="-120"/>
-                        </a:rPr>
-                        <a:t>✗</a:t>
-                      </a:r>
-                      <a:endParaRPr lang="en-US" sz="1900" dirty="0">
-                        <a:latin typeface="Segoe UI Symbol" charset="0"/>
-                        <a:ea typeface="Segoe UI Symbol" charset="0"/>
-                        <a:cs typeface="Segoe UI Symbol" charset="0"/>
-                      </a:endParaRPr>
-                    </a:p>
-                  </a:txBody>
-                  <a:tcPr marL="0" marR="0" marT="0" marB="0" anchor="ctr">
-                    <a:lnL w="12700" cap="flat" cmpd="sng" algn="ctr">
-                      <a:solidFill>
-                        <a:srgbClr val="B1BBC8"/>
-                      </a:solidFill>
-                      <a:prstDash val="solid"/>
-                      <a:round/>
-                      <a:headEnd type="none" w="med" len="med"/>
-                      <a:tailEnd type="none" w="med" len="med"/>
-                    </a:lnL>
-                    <a:lnR w="12700" cap="flat" cmpd="sng" algn="ctr">
-                      <a:solidFill>
-                        <a:srgbClr val="B1BBC8"/>
-                      </a:solidFill>
-                      <a:prstDash val="solid"/>
-                      <a:round/>
-                      <a:headEnd type="none" w="med" len="med"/>
-                      <a:tailEnd type="none" w="med" len="med"/>
-                    </a:lnR>
-                    <a:lnT w="12700" cap="flat" cmpd="sng" algn="ctr">
-                      <a:solidFill>
-                        <a:srgbClr val="B1BBC8"/>
-                      </a:solidFill>
-                      <a:prstDash val="solid"/>
-                      <a:round/>
-                      <a:headEnd type="none" w="med" len="med"/>
-                      <a:tailEnd type="none" w="med" len="med"/>
-                    </a:lnT>
-                    <a:lnB w="12700" cap="flat" cmpd="sng" algn="ctr">
-                      <a:solidFill>
-                        <a:srgbClr val="B1BBC8"/>
-                      </a:solidFill>
-                      <a:prstDash val="solid"/>
-                      <a:round/>
-                      <a:headEnd type="none" w="med" len="med"/>
-                      <a:tailEnd type="none" w="med" len="med"/>
-                    </a:lnB>
-                    <a:solidFill>
-                      <a:srgbClr val="FFFFFF"/>
-                    </a:solidFill>
-                  </a:tcPr>
-                </a:tc>
-                <a:tc>
-                  <a:txBody>
-                    <a:bodyPr/>
-                    <a:lstStyle/>
-                    <a:p>
-                      <a:pPr algn="ctr" indent="0" marL="0">
-                        <a:buNone/>
-                      </a:pPr>
-                      <a:r>
-                        <a:rPr lang="en-US" sz="1900" dirty="0">
-                          <a:solidFill>
-                            <a:srgbClr val="B23B3B"/>
-                          </a:solidFill>
-                          <a:latin typeface="Segoe UI Symbol" pitchFamily="34" charset="0"/>
-                          <a:ea typeface="Segoe UI Symbol" pitchFamily="34" charset="-122"/>
-                          <a:cs typeface="Segoe UI Symbol" pitchFamily="34" charset="-120"/>
-                        </a:rPr>
-                        <a:t>✗</a:t>
-                      </a:r>
-                      <a:endParaRPr lang="en-US" sz="1900" dirty="0">
-                        <a:latin typeface="Segoe UI Symbol" charset="0"/>
-                        <a:ea typeface="Segoe UI Symbol" charset="0"/>
-                        <a:cs typeface="Segoe UI Symbol" charset="0"/>
-                      </a:endParaRPr>
-                    </a:p>
-                  </a:txBody>
-                  <a:tcPr marL="0" marR="0" marT="0" marB="0" anchor="ctr">
+                  <a:tcPr marL="101600" marR="76200" marT="0" marB="0" anchor="ctr">
                     <a:lnL w="12700" cap="flat" cmpd="sng" algn="ctr">
                       <a:solidFill>
                         <a:srgbClr val="B1BBC8"/>
@@ -17337,7 +16725,7 @@
                           <a:ea typeface="Calibri" pitchFamily="34" charset="-122"/>
                           <a:cs typeface="Calibri" pitchFamily="34" charset="-120"/>
                         </a:rPr>
-                        <a:t>Guideline compliance with para cited</a:t>
+                        <a:t>Delay &amp; stuck-work early warning</a:t>
                       </a:r>
                       <a:endParaRPr lang="en-US" sz="1450" dirty="0">
                         <a:latin typeface="Calibri" charset="0"/>
@@ -17393,28 +16781,28 @@
                     <a:bodyPr/>
                     <a:lstStyle/>
                     <a:p>
-                      <a:pPr algn="ctr" indent="0" marL="0">
+                      <a:pPr indent="0" marL="0">
                         <a:buNone/>
                       </a:pPr>
                       <a:r>
-                        <a:rPr lang="en-US" sz="1900" dirty="0">
+                        <a:rPr lang="en-US" sz="1450" dirty="0">
                           <a:solidFill>
-                            <a:srgbClr val="2E7D4F"/>
+                            <a:srgbClr val="1A2F57"/>
                           </a:solidFill>
-                          <a:latin typeface="Segoe UI Symbol" pitchFamily="34" charset="0"/>
-                          <a:ea typeface="Segoe UI Symbol" pitchFamily="34" charset="-122"/>
-                          <a:cs typeface="Segoe UI Symbol" pitchFamily="34" charset="-120"/>
+                          <a:latin typeface="Calibri" pitchFamily="34" charset="0"/>
+                          <a:ea typeface="Calibri" pitchFamily="34" charset="-122"/>
+                          <a:cs typeface="Calibri" pitchFamily="34" charset="-120"/>
                         </a:rPr>
-                        <a:t>✓</a:t>
+                        <a:t>Stuck works + each office's track record</a:t>
                       </a:r>
-                      <a:endParaRPr lang="en-US" sz="1900" dirty="0">
-                        <a:latin typeface="Segoe UI Symbol" charset="0"/>
-                        <a:ea typeface="Segoe UI Symbol" charset="0"/>
-                        <a:cs typeface="Segoe UI Symbol" charset="0"/>
+                      <a:endParaRPr lang="en-US" sz="1450" dirty="0">
+                        <a:latin typeface="Calibri" charset="0"/>
+                        <a:ea typeface="Calibri" charset="0"/>
+                        <a:cs typeface="Calibri" charset="0"/>
                       </a:endParaRPr>
                     </a:p>
                   </a:txBody>
-                  <a:tcPr marL="0" marR="0" marT="0" marB="0" anchor="ctr">
+                  <a:tcPr marL="101600" marR="76200" marT="0" marB="0" anchor="ctr">
                     <a:lnL w="12700" cap="flat" cmpd="sng" algn="ctr">
                       <a:solidFill>
                         <a:srgbClr val="B1BBC8"/>
@@ -17461,164 +16849,28 @@
                     <a:bodyPr/>
                     <a:lstStyle/>
                     <a:p>
-                      <a:pPr algn="ctr" indent="0" marL="0">
+                      <a:pPr indent="0" marL="0">
                         <a:buNone/>
                       </a:pPr>
                       <a:r>
-                        <a:rPr lang="en-US" sz="1450" b="1" dirty="0">
+                        <a:rPr lang="en-US" sz="1400" b="1" dirty="0">
                           <a:solidFill>
-                            <a:srgbClr val="8A6D1F"/>
+                            <a:srgbClr val="2A4D88"/>
                           </a:solidFill>
                           <a:latin typeface="Calibri" pitchFamily="34" charset="0"/>
                           <a:ea typeface="Calibri" pitchFamily="34" charset="-122"/>
                           <a:cs typeface="Calibri" pitchFamily="34" charset="-120"/>
                         </a:rPr>
-                        <a:t>Partial</a:t>
+                        <a:t>Money &amp; time</a:t>
                       </a:r>
-                      <a:endParaRPr lang="en-US" sz="1450" dirty="0">
+                      <a:endParaRPr lang="en-US" sz="1400" dirty="0">
                         <a:latin typeface="Calibri" charset="0"/>
                         <a:ea typeface="Calibri" charset="0"/>
                         <a:cs typeface="Calibri" charset="0"/>
                       </a:endParaRPr>
                     </a:p>
                   </a:txBody>
-                  <a:tcPr marL="0" marR="0" marT="0" marB="0" anchor="ctr">
-                    <a:lnL w="12700" cap="flat" cmpd="sng" algn="ctr">
-                      <a:solidFill>
-                        <a:srgbClr val="B1BBC8"/>
-                      </a:solidFill>
-                      <a:prstDash val="solid"/>
-                      <a:round/>
-                      <a:headEnd type="none" w="med" len="med"/>
-                      <a:tailEnd type="none" w="med" len="med"/>
-                    </a:lnL>
-                    <a:lnR w="12700" cap="flat" cmpd="sng" algn="ctr">
-                      <a:solidFill>
-                        <a:srgbClr val="B1BBC8"/>
-                      </a:solidFill>
-                      <a:prstDash val="solid"/>
-                      <a:round/>
-                      <a:headEnd type="none" w="med" len="med"/>
-                      <a:tailEnd type="none" w="med" len="med"/>
-                    </a:lnR>
-                    <a:lnT w="12700" cap="flat" cmpd="sng" algn="ctr">
-                      <a:solidFill>
-                        <a:srgbClr val="B1BBC8"/>
-                      </a:solidFill>
-                      <a:prstDash val="solid"/>
-                      <a:round/>
-                      <a:headEnd type="none" w="med" len="med"/>
-                      <a:tailEnd type="none" w="med" len="med"/>
-                    </a:lnT>
-                    <a:lnB w="12700" cap="flat" cmpd="sng" algn="ctr">
-                      <a:solidFill>
-                        <a:srgbClr val="B1BBC8"/>
-                      </a:solidFill>
-                      <a:prstDash val="solid"/>
-                      <a:round/>
-                      <a:headEnd type="none" w="med" len="med"/>
-                      <a:tailEnd type="none" w="med" len="med"/>
-                    </a:lnB>
-                    <a:solidFill>
-                      <a:srgbClr val="FFFFFF"/>
-                    </a:solidFill>
-                  </a:tcPr>
-                </a:tc>
-                <a:tc>
-                  <a:txBody>
-                    <a:bodyPr/>
-                    <a:lstStyle/>
-                    <a:p>
-                      <a:pPr algn="ctr" indent="0" marL="0">
-                        <a:buNone/>
-                      </a:pPr>
-                      <a:r>
-                        <a:rPr lang="en-US" sz="1900" dirty="0">
-                          <a:solidFill>
-                            <a:srgbClr val="2E7D4F"/>
-                          </a:solidFill>
-                          <a:latin typeface="Segoe UI Symbol" pitchFamily="34" charset="0"/>
-                          <a:ea typeface="Segoe UI Symbol" pitchFamily="34" charset="-122"/>
-                          <a:cs typeface="Segoe UI Symbol" pitchFamily="34" charset="-120"/>
-                        </a:rPr>
-                        <a:t>✓</a:t>
-                      </a:r>
-                      <a:endParaRPr lang="en-US" sz="1900" dirty="0">
-                        <a:latin typeface="Segoe UI Symbol" charset="0"/>
-                        <a:ea typeface="Segoe UI Symbol" charset="0"/>
-                        <a:cs typeface="Segoe UI Symbol" charset="0"/>
-                      </a:endParaRPr>
-                    </a:p>
-                  </a:txBody>
-                  <a:tcPr marL="0" marR="0" marT="0" marB="0" anchor="ctr">
-                    <a:lnL w="12700" cap="flat" cmpd="sng" algn="ctr">
-                      <a:solidFill>
-                        <a:srgbClr val="B1BBC8"/>
-                      </a:solidFill>
-                      <a:prstDash val="solid"/>
-                      <a:round/>
-                      <a:headEnd type="none" w="med" len="med"/>
-                      <a:tailEnd type="none" w="med" len="med"/>
-                    </a:lnL>
-                    <a:lnR w="12700" cap="flat" cmpd="sng" algn="ctr">
-                      <a:solidFill>
-                        <a:srgbClr val="B1BBC8"/>
-                      </a:solidFill>
-                      <a:prstDash val="solid"/>
-                      <a:round/>
-                      <a:headEnd type="none" w="med" len="med"/>
-                      <a:tailEnd type="none" w="med" len="med"/>
-                    </a:lnR>
-                    <a:lnT w="12700" cap="flat" cmpd="sng" algn="ctr">
-                      <a:solidFill>
-                        <a:srgbClr val="B1BBC8"/>
-                      </a:solidFill>
-                      <a:prstDash val="solid"/>
-                      <a:round/>
-                      <a:headEnd type="none" w="med" len="med"/>
-                      <a:tailEnd type="none" w="med" len="med"/>
-                    </a:lnT>
-                    <a:lnB w="12700" cap="flat" cmpd="sng" algn="ctr">
-                      <a:solidFill>
-                        <a:srgbClr val="B1BBC8"/>
-                      </a:solidFill>
-                      <a:prstDash val="solid"/>
-                      <a:round/>
-                      <a:headEnd type="none" w="med" len="med"/>
-                      <a:tailEnd type="none" w="med" len="med"/>
-                    </a:lnB>
-                    <a:solidFill>
-                      <a:srgbClr val="FFFFFF"/>
-                    </a:solidFill>
-                  </a:tcPr>
-                </a:tc>
-                <a:tc>
-                  <a:txBody>
-                    <a:bodyPr/>
-                    <a:lstStyle/>
-                    <a:p>
-                      <a:pPr algn="ctr" indent="0" marL="0">
-                        <a:buNone/>
-                      </a:pPr>
-                      <a:r>
-                        <a:rPr lang="en-US" sz="1900" dirty="0">
-                          <a:solidFill>
-                            <a:srgbClr val="B23B3B"/>
-                          </a:solidFill>
-                          <a:latin typeface="Segoe UI Symbol" pitchFamily="34" charset="0"/>
-                          <a:ea typeface="Segoe UI Symbol" pitchFamily="34" charset="-122"/>
-                          <a:cs typeface="Segoe UI Symbol" pitchFamily="34" charset="-120"/>
-                        </a:rPr>
-                        <a:t>✗</a:t>
-                      </a:r>
-                      <a:endParaRPr lang="en-US" sz="1900" dirty="0">
-                        <a:latin typeface="Segoe UI Symbol" charset="0"/>
-                        <a:ea typeface="Segoe UI Symbol" charset="0"/>
-                        <a:cs typeface="Segoe UI Symbol" charset="0"/>
-                      </a:endParaRPr>
-                    </a:p>
-                  </a:txBody>
-                  <a:tcPr marL="0" marR="0" marT="0" marB="0" anchor="ctr">
+                  <a:tcPr marL="101600" marR="76200" marT="0" marB="0" anchor="ctr">
                     <a:lnL w="12700" cap="flat" cmpd="sng" algn="ctr">
                       <a:solidFill>
                         <a:srgbClr val="B1BBC8"/>
@@ -17679,7 +16931,7 @@
                           <a:ea typeface="Calibri" pitchFamily="34" charset="-122"/>
                           <a:cs typeface="Calibri" pitchFamily="34" charset="-120"/>
                         </a:rPr>
-                        <a:t>Delay / overrun early warning</a:t>
+                        <a:t>Citizen confirmation &amp; field learning</a:t>
                       </a:r>
                       <a:endParaRPr lang="en-US" sz="1450" dirty="0">
                         <a:latin typeface="Calibri" charset="0"/>
@@ -17735,28 +16987,28 @@
                     <a:bodyPr/>
                     <a:lstStyle/>
                     <a:p>
-                      <a:pPr algn="ctr" indent="0" marL="0">
+                      <a:pPr indent="0" marL="0">
                         <a:buNone/>
                       </a:pPr>
                       <a:r>
-                        <a:rPr lang="en-US" sz="1900" dirty="0">
+                        <a:rPr lang="en-US" sz="1450" dirty="0">
                           <a:solidFill>
-                            <a:srgbClr val="2E7D4F"/>
+                            <a:srgbClr val="1A2F57"/>
                           </a:solidFill>
-                          <a:latin typeface="Segoe UI Symbol" pitchFamily="34" charset="0"/>
-                          <a:ea typeface="Segoe UI Symbol" pitchFamily="34" charset="-122"/>
-                          <a:cs typeface="Segoe UI Symbol" pitchFamily="34" charset="-120"/>
+                          <a:latin typeface="Calibri" pitchFamily="34" charset="0"/>
+                          <a:ea typeface="Calibri" pitchFamily="34" charset="-122"/>
+                          <a:cs typeface="Calibri" pitchFamily="34" charset="-120"/>
                         </a:rPr>
-                        <a:t>✓</a:t>
+                        <a:t>QR at site; officer verdicts retrain agents</a:t>
                       </a:r>
-                      <a:endParaRPr lang="en-US" sz="1900" dirty="0">
-                        <a:latin typeface="Segoe UI Symbol" charset="0"/>
-                        <a:ea typeface="Segoe UI Symbol" charset="0"/>
-                        <a:cs typeface="Segoe UI Symbol" charset="0"/>
+                      <a:endParaRPr lang="en-US" sz="1450" dirty="0">
+                        <a:latin typeface="Calibri" charset="0"/>
+                        <a:ea typeface="Calibri" charset="0"/>
+                        <a:cs typeface="Calibri" charset="0"/>
                       </a:endParaRPr>
                     </a:p>
                   </a:txBody>
-                  <a:tcPr marL="0" marR="0" marT="0" marB="0" anchor="ctr">
+                  <a:tcPr marL="101600" marR="76200" marT="0" marB="0" anchor="ctr">
                     <a:lnL w="12700" cap="flat" cmpd="sng" algn="ctr">
                       <a:solidFill>
                         <a:srgbClr val="B1BBC8"/>
@@ -17803,164 +17055,28 @@
                     <a:bodyPr/>
                     <a:lstStyle/>
                     <a:p>
-                      <a:pPr algn="ctr" indent="0" marL="0">
+                      <a:pPr indent="0" marL="0">
                         <a:buNone/>
                       </a:pPr>
                       <a:r>
-                        <a:rPr lang="en-US" sz="1450" b="1" dirty="0">
+                        <a:rPr lang="en-US" sz="1400" b="1" dirty="0">
                           <a:solidFill>
-                            <a:srgbClr val="8A6D1F"/>
+                            <a:srgbClr val="2A4D88"/>
                           </a:solidFill>
                           <a:latin typeface="Calibri" pitchFamily="34" charset="0"/>
                           <a:ea typeface="Calibri" pitchFamily="34" charset="-122"/>
                           <a:cs typeface="Calibri" pitchFamily="34" charset="-120"/>
                         </a:rPr>
-                        <a:t>Partial</a:t>
+                        <a:t>After completion</a:t>
                       </a:r>
-                      <a:endParaRPr lang="en-US" sz="1450" dirty="0">
+                      <a:endParaRPr lang="en-US" sz="1400" dirty="0">
                         <a:latin typeface="Calibri" charset="0"/>
                         <a:ea typeface="Calibri" charset="0"/>
                         <a:cs typeface="Calibri" charset="0"/>
                       </a:endParaRPr>
                     </a:p>
                   </a:txBody>
-                  <a:tcPr marL="0" marR="0" marT="0" marB="0" anchor="ctr">
-                    <a:lnL w="12700" cap="flat" cmpd="sng" algn="ctr">
-                      <a:solidFill>
-                        <a:srgbClr val="B1BBC8"/>
-                      </a:solidFill>
-                      <a:prstDash val="solid"/>
-                      <a:round/>
-                      <a:headEnd type="none" w="med" len="med"/>
-                      <a:tailEnd type="none" w="med" len="med"/>
-                    </a:lnL>
-                    <a:lnR w="12700" cap="flat" cmpd="sng" algn="ctr">
-                      <a:solidFill>
-                        <a:srgbClr val="B1BBC8"/>
-                      </a:solidFill>
-                      <a:prstDash val="solid"/>
-                      <a:round/>
-                      <a:headEnd type="none" w="med" len="med"/>
-                      <a:tailEnd type="none" w="med" len="med"/>
-                    </a:lnR>
-                    <a:lnT w="12700" cap="flat" cmpd="sng" algn="ctr">
-                      <a:solidFill>
-                        <a:srgbClr val="B1BBC8"/>
-                      </a:solidFill>
-                      <a:prstDash val="solid"/>
-                      <a:round/>
-                      <a:headEnd type="none" w="med" len="med"/>
-                      <a:tailEnd type="none" w="med" len="med"/>
-                    </a:lnT>
-                    <a:lnB w="12700" cap="flat" cmpd="sng" algn="ctr">
-                      <a:solidFill>
-                        <a:srgbClr val="B1BBC8"/>
-                      </a:solidFill>
-                      <a:prstDash val="solid"/>
-                      <a:round/>
-                      <a:headEnd type="none" w="med" len="med"/>
-                      <a:tailEnd type="none" w="med" len="med"/>
-                    </a:lnB>
-                    <a:solidFill>
-                      <a:srgbClr val="FFFFFF"/>
-                    </a:solidFill>
-                  </a:tcPr>
-                </a:tc>
-                <a:tc>
-                  <a:txBody>
-                    <a:bodyPr/>
-                    <a:lstStyle/>
-                    <a:p>
-                      <a:pPr algn="ctr" indent="0" marL="0">
-                        <a:buNone/>
-                      </a:pPr>
-                      <a:r>
-                        <a:rPr lang="en-US" sz="1900" dirty="0">
-                          <a:solidFill>
-                            <a:srgbClr val="B23B3B"/>
-                          </a:solidFill>
-                          <a:latin typeface="Segoe UI Symbol" pitchFamily="34" charset="0"/>
-                          <a:ea typeface="Segoe UI Symbol" pitchFamily="34" charset="-122"/>
-                          <a:cs typeface="Segoe UI Symbol" pitchFamily="34" charset="-120"/>
-                        </a:rPr>
-                        <a:t>✗</a:t>
-                      </a:r>
-                      <a:endParaRPr lang="en-US" sz="1900" dirty="0">
-                        <a:latin typeface="Segoe UI Symbol" charset="0"/>
-                        <a:ea typeface="Segoe UI Symbol" charset="0"/>
-                        <a:cs typeface="Segoe UI Symbol" charset="0"/>
-                      </a:endParaRPr>
-                    </a:p>
-                  </a:txBody>
-                  <a:tcPr marL="0" marR="0" marT="0" marB="0" anchor="ctr">
-                    <a:lnL w="12700" cap="flat" cmpd="sng" algn="ctr">
-                      <a:solidFill>
-                        <a:srgbClr val="B1BBC8"/>
-                      </a:solidFill>
-                      <a:prstDash val="solid"/>
-                      <a:round/>
-                      <a:headEnd type="none" w="med" len="med"/>
-                      <a:tailEnd type="none" w="med" len="med"/>
-                    </a:lnL>
-                    <a:lnR w="12700" cap="flat" cmpd="sng" algn="ctr">
-                      <a:solidFill>
-                        <a:srgbClr val="B1BBC8"/>
-                      </a:solidFill>
-                      <a:prstDash val="solid"/>
-                      <a:round/>
-                      <a:headEnd type="none" w="med" len="med"/>
-                      <a:tailEnd type="none" w="med" len="med"/>
-                    </a:lnR>
-                    <a:lnT w="12700" cap="flat" cmpd="sng" algn="ctr">
-                      <a:solidFill>
-                        <a:srgbClr val="B1BBC8"/>
-                      </a:solidFill>
-                      <a:prstDash val="solid"/>
-                      <a:round/>
-                      <a:headEnd type="none" w="med" len="med"/>
-                      <a:tailEnd type="none" w="med" len="med"/>
-                    </a:lnT>
-                    <a:lnB w="12700" cap="flat" cmpd="sng" algn="ctr">
-                      <a:solidFill>
-                        <a:srgbClr val="B1BBC8"/>
-                      </a:solidFill>
-                      <a:prstDash val="solid"/>
-                      <a:round/>
-                      <a:headEnd type="none" w="med" len="med"/>
-                      <a:tailEnd type="none" w="med" len="med"/>
-                    </a:lnB>
-                    <a:solidFill>
-                      <a:srgbClr val="FFFFFF"/>
-                    </a:solidFill>
-                  </a:tcPr>
-                </a:tc>
-                <a:tc>
-                  <a:txBody>
-                    <a:bodyPr/>
-                    <a:lstStyle/>
-                    <a:p>
-                      <a:pPr algn="ctr" indent="0" marL="0">
-                        <a:buNone/>
-                      </a:pPr>
-                      <a:r>
-                        <a:rPr lang="en-US" sz="1450" b="1" dirty="0">
-                          <a:solidFill>
-                            <a:srgbClr val="8A6D1F"/>
-                          </a:solidFill>
-                          <a:latin typeface="Calibri" pitchFamily="34" charset="0"/>
-                          <a:ea typeface="Calibri" pitchFamily="34" charset="-122"/>
-                          <a:cs typeface="Calibri" pitchFamily="34" charset="-120"/>
-                        </a:rPr>
-                        <a:t>Partial</a:t>
-                      </a:r>
-                      <a:endParaRPr lang="en-US" sz="1450" dirty="0">
-                        <a:latin typeface="Calibri" charset="0"/>
-                        <a:ea typeface="Calibri" charset="0"/>
-                        <a:cs typeface="Calibri" charset="0"/>
-                      </a:endParaRPr>
-                    </a:p>
-                  </a:txBody>
-                  <a:tcPr marL="0" marR="0" marT="0" marB="0" anchor="ctr">
+                  <a:tcPr marL="101600" marR="76200" marT="0" marB="0" anchor="ctr">
                     <a:lnL w="12700" cap="flat" cmpd="sng" algn="ctr">
                       <a:solidFill>
                         <a:srgbClr val="B1BBC8"/>
@@ -18077,28 +17193,28 @@
                     <a:bodyPr/>
                     <a:lstStyle/>
                     <a:p>
-                      <a:pPr algn="ctr" indent="0" marL="0">
+                      <a:pPr indent="0" marL="0">
                         <a:buNone/>
                       </a:pPr>
                       <a:r>
-                        <a:rPr lang="en-US" sz="1900" dirty="0">
+                        <a:rPr lang="en-US" sz="1450" dirty="0">
                           <a:solidFill>
-                            <a:srgbClr val="2E7D4F"/>
+                            <a:srgbClr val="1A2F57"/>
                           </a:solidFill>
-                          <a:latin typeface="Segoe UI Symbol" pitchFamily="34" charset="0"/>
-                          <a:ea typeface="Segoe UI Symbol" pitchFamily="34" charset="-122"/>
-                          <a:cs typeface="Segoe UI Symbol" pitchFamily="34" charset="-120"/>
+                          <a:latin typeface="Calibri" pitchFamily="34" charset="0"/>
+                          <a:ea typeface="Calibri" pitchFamily="34" charset="-122"/>
+                          <a:cs typeface="Calibri" pitchFamily="34" charset="-120"/>
                         </a:rPr>
-                        <a:t>✓</a:t>
+                        <a:t>All agents fused + top-3 reasons</a:t>
                       </a:r>
-                      <a:endParaRPr lang="en-US" sz="1900" dirty="0">
-                        <a:latin typeface="Segoe UI Symbol" charset="0"/>
-                        <a:ea typeface="Segoe UI Symbol" charset="0"/>
-                        <a:cs typeface="Segoe UI Symbol" charset="0"/>
+                      <a:endParaRPr lang="en-US" sz="1450" dirty="0">
+                        <a:latin typeface="Calibri" charset="0"/>
+                        <a:ea typeface="Calibri" charset="0"/>
+                        <a:cs typeface="Calibri" charset="0"/>
                       </a:endParaRPr>
                     </a:p>
                   </a:txBody>
-                  <a:tcPr marL="0" marR="0" marT="0" marB="0" anchor="ctr">
+                  <a:tcPr marL="101600" marR="76200" marT="0" marB="0" anchor="ctr">
                     <a:lnL w="12700" cap="flat" cmpd="sng" algn="ctr">
                       <a:solidFill>
                         <a:srgbClr val="B1BBC8"/>
@@ -18145,164 +17261,28 @@
                     <a:bodyPr/>
                     <a:lstStyle/>
                     <a:p>
-                      <a:pPr algn="ctr" indent="0" marL="0">
+                      <a:pPr indent="0" marL="0">
                         <a:buNone/>
                       </a:pPr>
                       <a:r>
-                        <a:rPr lang="en-US" sz="1900" dirty="0">
+                        <a:rPr lang="en-US" sz="1400" b="1" dirty="0">
                           <a:solidFill>
-                            <a:srgbClr val="B23B3B"/>
+                            <a:srgbClr val="2A4D88"/>
                           </a:solidFill>
-                          <a:latin typeface="Segoe UI Symbol" pitchFamily="34" charset="0"/>
-                          <a:ea typeface="Segoe UI Symbol" pitchFamily="34" charset="-122"/>
-                          <a:cs typeface="Segoe UI Symbol" pitchFamily="34" charset="-120"/>
+                          <a:latin typeface="Calibri" pitchFamily="34" charset="0"/>
+                          <a:ea typeface="Calibri" pitchFamily="34" charset="-122"/>
+                          <a:cs typeface="Calibri" pitchFamily="34" charset="-120"/>
                         </a:rPr>
-                        <a:t>✗</a:t>
+                        <a:t>Every work</a:t>
                       </a:r>
-                      <a:endParaRPr lang="en-US" sz="1900" dirty="0">
-                        <a:latin typeface="Segoe UI Symbol" charset="0"/>
-                        <a:ea typeface="Segoe UI Symbol" charset="0"/>
-                        <a:cs typeface="Segoe UI Symbol" charset="0"/>
+                      <a:endParaRPr lang="en-US" sz="1400" dirty="0">
+                        <a:latin typeface="Calibri" charset="0"/>
+                        <a:ea typeface="Calibri" charset="0"/>
+                        <a:cs typeface="Calibri" charset="0"/>
                       </a:endParaRPr>
                     </a:p>
                   </a:txBody>
-                  <a:tcPr marL="0" marR="0" marT="0" marB="0" anchor="ctr">
-                    <a:lnL w="12700" cap="flat" cmpd="sng" algn="ctr">
-                      <a:solidFill>
-                        <a:srgbClr val="B1BBC8"/>
-                      </a:solidFill>
-                      <a:prstDash val="solid"/>
-                      <a:round/>
-                      <a:headEnd type="none" w="med" len="med"/>
-                      <a:tailEnd type="none" w="med" len="med"/>
-                    </a:lnL>
-                    <a:lnR w="12700" cap="flat" cmpd="sng" algn="ctr">
-                      <a:solidFill>
-                        <a:srgbClr val="B1BBC8"/>
-                      </a:solidFill>
-                      <a:prstDash val="solid"/>
-                      <a:round/>
-                      <a:headEnd type="none" w="med" len="med"/>
-                      <a:tailEnd type="none" w="med" len="med"/>
-                    </a:lnR>
-                    <a:lnT w="12700" cap="flat" cmpd="sng" algn="ctr">
-                      <a:solidFill>
-                        <a:srgbClr val="B1BBC8"/>
-                      </a:solidFill>
-                      <a:prstDash val="solid"/>
-                      <a:round/>
-                      <a:headEnd type="none" w="med" len="med"/>
-                      <a:tailEnd type="none" w="med" len="med"/>
-                    </a:lnT>
-                    <a:lnB w="12700" cap="flat" cmpd="sng" algn="ctr">
-                      <a:solidFill>
-                        <a:srgbClr val="B1BBC8"/>
-                      </a:solidFill>
-                      <a:prstDash val="solid"/>
-                      <a:round/>
-                      <a:headEnd type="none" w="med" len="med"/>
-                      <a:tailEnd type="none" w="med" len="med"/>
-                    </a:lnB>
-                    <a:solidFill>
-                      <a:srgbClr val="FFFFFF"/>
-                    </a:solidFill>
-                  </a:tcPr>
-                </a:tc>
-                <a:tc>
-                  <a:txBody>
-                    <a:bodyPr/>
-                    <a:lstStyle/>
-                    <a:p>
-                      <a:pPr algn="ctr" indent="0" marL="0">
-                        <a:buNone/>
-                      </a:pPr>
-                      <a:r>
-                        <a:rPr lang="en-US" sz="1900" dirty="0">
-                          <a:solidFill>
-                            <a:srgbClr val="B23B3B"/>
-                          </a:solidFill>
-                          <a:latin typeface="Segoe UI Symbol" pitchFamily="34" charset="0"/>
-                          <a:ea typeface="Segoe UI Symbol" pitchFamily="34" charset="-122"/>
-                          <a:cs typeface="Segoe UI Symbol" pitchFamily="34" charset="-120"/>
-                        </a:rPr>
-                        <a:t>✗</a:t>
-                      </a:r>
-                      <a:endParaRPr lang="en-US" sz="1900" dirty="0">
-                        <a:latin typeface="Segoe UI Symbol" charset="0"/>
-                        <a:ea typeface="Segoe UI Symbol" charset="0"/>
-                        <a:cs typeface="Segoe UI Symbol" charset="0"/>
-                      </a:endParaRPr>
-                    </a:p>
-                  </a:txBody>
-                  <a:tcPr marL="0" marR="0" marT="0" marB="0" anchor="ctr">
-                    <a:lnL w="12700" cap="flat" cmpd="sng" algn="ctr">
-                      <a:solidFill>
-                        <a:srgbClr val="B1BBC8"/>
-                      </a:solidFill>
-                      <a:prstDash val="solid"/>
-                      <a:round/>
-                      <a:headEnd type="none" w="med" len="med"/>
-                      <a:tailEnd type="none" w="med" len="med"/>
-                    </a:lnL>
-                    <a:lnR w="12700" cap="flat" cmpd="sng" algn="ctr">
-                      <a:solidFill>
-                        <a:srgbClr val="B1BBC8"/>
-                      </a:solidFill>
-                      <a:prstDash val="solid"/>
-                      <a:round/>
-                      <a:headEnd type="none" w="med" len="med"/>
-                      <a:tailEnd type="none" w="med" len="med"/>
-                    </a:lnR>
-                    <a:lnT w="12700" cap="flat" cmpd="sng" algn="ctr">
-                      <a:solidFill>
-                        <a:srgbClr val="B1BBC8"/>
-                      </a:solidFill>
-                      <a:prstDash val="solid"/>
-                      <a:round/>
-                      <a:headEnd type="none" w="med" len="med"/>
-                      <a:tailEnd type="none" w="med" len="med"/>
-                    </a:lnT>
-                    <a:lnB w="12700" cap="flat" cmpd="sng" algn="ctr">
-                      <a:solidFill>
-                        <a:srgbClr val="B1BBC8"/>
-                      </a:solidFill>
-                      <a:prstDash val="solid"/>
-                      <a:round/>
-                      <a:headEnd type="none" w="med" len="med"/>
-                      <a:tailEnd type="none" w="med" len="med"/>
-                    </a:lnB>
-                    <a:solidFill>
-                      <a:srgbClr val="FFFFFF"/>
-                    </a:solidFill>
-                  </a:tcPr>
-                </a:tc>
-                <a:tc>
-                  <a:txBody>
-                    <a:bodyPr/>
-                    <a:lstStyle/>
-                    <a:p>
-                      <a:pPr algn="ctr" indent="0" marL="0">
-                        <a:buNone/>
-                      </a:pPr>
-                      <a:r>
-                        <a:rPr lang="en-US" sz="1900" dirty="0">
-                          <a:solidFill>
-                            <a:srgbClr val="B23B3B"/>
-                          </a:solidFill>
-                          <a:latin typeface="Segoe UI Symbol" pitchFamily="34" charset="0"/>
-                          <a:ea typeface="Segoe UI Symbol" pitchFamily="34" charset="-122"/>
-                          <a:cs typeface="Segoe UI Symbol" pitchFamily="34" charset="-120"/>
-                        </a:rPr>
-                        <a:t>✗</a:t>
-                      </a:r>
-                      <a:endParaRPr lang="en-US" sz="1900" dirty="0">
-                        <a:latin typeface="Segoe UI Symbol" charset="0"/>
-                        <a:ea typeface="Segoe UI Symbol" charset="0"/>
-                        <a:cs typeface="Segoe UI Symbol" charset="0"/>
-                      </a:endParaRPr>
-                    </a:p>
-                  </a:txBody>
-                  <a:tcPr marL="0" marR="0" marT="0" marB="0" anchor="ctr">
+                  <a:tcPr marL="101600" marR="76200" marT="0" marB="0" anchor="ctr">
                     <a:lnL w="12700" cap="flat" cmpd="sng" algn="ctr">
                       <a:solidFill>
                         <a:srgbClr val="B1BBC8"/>
@@ -18419,28 +17399,28 @@
                     <a:bodyPr/>
                     <a:lstStyle/>
                     <a:p>
-                      <a:pPr algn="ctr" indent="0" marL="0">
+                      <a:pPr indent="0" marL="0">
                         <a:buNone/>
                       </a:pPr>
                       <a:r>
-                        <a:rPr lang="en-US" sz="1900" dirty="0">
+                        <a:rPr lang="en-US" sz="1450" dirty="0">
                           <a:solidFill>
-                            <a:srgbClr val="2E7D4F"/>
+                            <a:srgbClr val="1A2F57"/>
                           </a:solidFill>
-                          <a:latin typeface="Segoe UI Symbol" pitchFamily="34" charset="0"/>
-                          <a:ea typeface="Segoe UI Symbol" pitchFamily="34" charset="-122"/>
-                          <a:cs typeface="Segoe UI Symbol" pitchFamily="34" charset="-120"/>
+                          <a:latin typeface="Calibri" pitchFamily="34" charset="0"/>
+                          <a:ea typeface="Calibri" pitchFamily="34" charset="-122"/>
+                          <a:cs typeface="Calibri" pitchFamily="34" charset="-120"/>
                         </a:rPr>
-                        <a:t>✓</a:t>
+                        <a:t>Picks the mandatory 10% of visits, routed</a:t>
                       </a:r>
-                      <a:endParaRPr lang="en-US" sz="1900" dirty="0">
-                        <a:latin typeface="Segoe UI Symbol" charset="0"/>
-                        <a:ea typeface="Segoe UI Symbol" charset="0"/>
-                        <a:cs typeface="Segoe UI Symbol" charset="0"/>
+                      <a:endParaRPr lang="en-US" sz="1450" dirty="0">
+                        <a:latin typeface="Calibri" charset="0"/>
+                        <a:ea typeface="Calibri" charset="0"/>
+                        <a:cs typeface="Calibri" charset="0"/>
                       </a:endParaRPr>
                     </a:p>
                   </a:txBody>
-                  <a:tcPr marL="0" marR="0" marT="0" marB="0" anchor="ctr">
+                  <a:tcPr marL="101600" marR="76200" marT="0" marB="0" anchor="ctr">
                     <a:lnL w="12700" cap="flat" cmpd="sng" algn="ctr">
                       <a:solidFill>
                         <a:srgbClr val="B1BBC8"/>
@@ -18487,506 +17467,28 @@
                     <a:bodyPr/>
                     <a:lstStyle/>
                     <a:p>
-                      <a:pPr algn="ctr" indent="0" marL="0">
-                        <a:buNone/>
-                      </a:pPr>
-                      <a:r>
-                        <a:rPr lang="en-US" sz="1900" dirty="0">
-                          <a:solidFill>
-                            <a:srgbClr val="B23B3B"/>
-                          </a:solidFill>
-                          <a:latin typeface="Segoe UI Symbol" pitchFamily="34" charset="0"/>
-                          <a:ea typeface="Segoe UI Symbol" pitchFamily="34" charset="-122"/>
-                          <a:cs typeface="Segoe UI Symbol" pitchFamily="34" charset="-120"/>
-                        </a:rPr>
-                        <a:t>✗</a:t>
-                      </a:r>
-                      <a:endParaRPr lang="en-US" sz="1900" dirty="0">
-                        <a:latin typeface="Segoe UI Symbol" charset="0"/>
-                        <a:ea typeface="Segoe UI Symbol" charset="0"/>
-                        <a:cs typeface="Segoe UI Symbol" charset="0"/>
-                      </a:endParaRPr>
-                    </a:p>
-                  </a:txBody>
-                  <a:tcPr marL="0" marR="0" marT="0" marB="0" anchor="ctr">
-                    <a:lnL w="12700" cap="flat" cmpd="sng" algn="ctr">
-                      <a:solidFill>
-                        <a:srgbClr val="B1BBC8"/>
-                      </a:solidFill>
-                      <a:prstDash val="solid"/>
-                      <a:round/>
-                      <a:headEnd type="none" w="med" len="med"/>
-                      <a:tailEnd type="none" w="med" len="med"/>
-                    </a:lnL>
-                    <a:lnR w="12700" cap="flat" cmpd="sng" algn="ctr">
-                      <a:solidFill>
-                        <a:srgbClr val="B1BBC8"/>
-                      </a:solidFill>
-                      <a:prstDash val="solid"/>
-                      <a:round/>
-                      <a:headEnd type="none" w="med" len="med"/>
-                      <a:tailEnd type="none" w="med" len="med"/>
-                    </a:lnR>
-                    <a:lnT w="12700" cap="flat" cmpd="sng" algn="ctr">
-                      <a:solidFill>
-                        <a:srgbClr val="B1BBC8"/>
-                      </a:solidFill>
-                      <a:prstDash val="solid"/>
-                      <a:round/>
-                      <a:headEnd type="none" w="med" len="med"/>
-                      <a:tailEnd type="none" w="med" len="med"/>
-                    </a:lnT>
-                    <a:lnB w="12700" cap="flat" cmpd="sng" algn="ctr">
-                      <a:solidFill>
-                        <a:srgbClr val="B1BBC8"/>
-                      </a:solidFill>
-                      <a:prstDash val="solid"/>
-                      <a:round/>
-                      <a:headEnd type="none" w="med" len="med"/>
-                      <a:tailEnd type="none" w="med" len="med"/>
-                    </a:lnB>
-                    <a:solidFill>
-                      <a:srgbClr val="FFFFFF"/>
-                    </a:solidFill>
-                  </a:tcPr>
-                </a:tc>
-                <a:tc>
-                  <a:txBody>
-                    <a:bodyPr/>
-                    <a:lstStyle/>
-                    <a:p>
-                      <a:pPr algn="ctr" indent="0" marL="0">
-                        <a:buNone/>
-                      </a:pPr>
-                      <a:r>
-                        <a:rPr lang="en-US" sz="1900" dirty="0">
-                          <a:solidFill>
-                            <a:srgbClr val="B23B3B"/>
-                          </a:solidFill>
-                          <a:latin typeface="Segoe UI Symbol" pitchFamily="34" charset="0"/>
-                          <a:ea typeface="Segoe UI Symbol" pitchFamily="34" charset="-122"/>
-                          <a:cs typeface="Segoe UI Symbol" pitchFamily="34" charset="-120"/>
-                        </a:rPr>
-                        <a:t>✗</a:t>
-                      </a:r>
-                      <a:endParaRPr lang="en-US" sz="1900" dirty="0">
-                        <a:latin typeface="Segoe UI Symbol" charset="0"/>
-                        <a:ea typeface="Segoe UI Symbol" charset="0"/>
-                        <a:cs typeface="Segoe UI Symbol" charset="0"/>
-                      </a:endParaRPr>
-                    </a:p>
-                  </a:txBody>
-                  <a:tcPr marL="0" marR="0" marT="0" marB="0" anchor="ctr">
-                    <a:lnL w="12700" cap="flat" cmpd="sng" algn="ctr">
-                      <a:solidFill>
-                        <a:srgbClr val="B1BBC8"/>
-                      </a:solidFill>
-                      <a:prstDash val="solid"/>
-                      <a:round/>
-                      <a:headEnd type="none" w="med" len="med"/>
-                      <a:tailEnd type="none" w="med" len="med"/>
-                    </a:lnL>
-                    <a:lnR w="12700" cap="flat" cmpd="sng" algn="ctr">
-                      <a:solidFill>
-                        <a:srgbClr val="B1BBC8"/>
-                      </a:solidFill>
-                      <a:prstDash val="solid"/>
-                      <a:round/>
-                      <a:headEnd type="none" w="med" len="med"/>
-                      <a:tailEnd type="none" w="med" len="med"/>
-                    </a:lnR>
-                    <a:lnT w="12700" cap="flat" cmpd="sng" algn="ctr">
-                      <a:solidFill>
-                        <a:srgbClr val="B1BBC8"/>
-                      </a:solidFill>
-                      <a:prstDash val="solid"/>
-                      <a:round/>
-                      <a:headEnd type="none" w="med" len="med"/>
-                      <a:tailEnd type="none" w="med" len="med"/>
-                    </a:lnT>
-                    <a:lnB w="12700" cap="flat" cmpd="sng" algn="ctr">
-                      <a:solidFill>
-                        <a:srgbClr val="B1BBC8"/>
-                      </a:solidFill>
-                      <a:prstDash val="solid"/>
-                      <a:round/>
-                      <a:headEnd type="none" w="med" len="med"/>
-                      <a:tailEnd type="none" w="med" len="med"/>
-                    </a:lnB>
-                    <a:solidFill>
-                      <a:srgbClr val="FFFFFF"/>
-                    </a:solidFill>
-                  </a:tcPr>
-                </a:tc>
-                <a:tc>
-                  <a:txBody>
-                    <a:bodyPr/>
-                    <a:lstStyle/>
-                    <a:p>
-                      <a:pPr algn="ctr" indent="0" marL="0">
-                        <a:buNone/>
-                      </a:pPr>
-                      <a:r>
-                        <a:rPr lang="en-US" sz="1900" dirty="0">
-                          <a:solidFill>
-                            <a:srgbClr val="B23B3B"/>
-                          </a:solidFill>
-                          <a:latin typeface="Segoe UI Symbol" pitchFamily="34" charset="0"/>
-                          <a:ea typeface="Segoe UI Symbol" pitchFamily="34" charset="-122"/>
-                          <a:cs typeface="Segoe UI Symbol" pitchFamily="34" charset="-120"/>
-                        </a:rPr>
-                        <a:t>✗</a:t>
-                      </a:r>
-                      <a:endParaRPr lang="en-US" sz="1900" dirty="0">
-                        <a:latin typeface="Segoe UI Symbol" charset="0"/>
-                        <a:ea typeface="Segoe UI Symbol" charset="0"/>
-                        <a:cs typeface="Segoe UI Symbol" charset="0"/>
-                      </a:endParaRPr>
-                    </a:p>
-                  </a:txBody>
-                  <a:tcPr marL="0" marR="0" marT="0" marB="0" anchor="ctr">
-                    <a:lnL w="12700" cap="flat" cmpd="sng" algn="ctr">
-                      <a:solidFill>
-                        <a:srgbClr val="B1BBC8"/>
-                      </a:solidFill>
-                      <a:prstDash val="solid"/>
-                      <a:round/>
-                      <a:headEnd type="none" w="med" len="med"/>
-                      <a:tailEnd type="none" w="med" len="med"/>
-                    </a:lnL>
-                    <a:lnR w="12700" cap="flat" cmpd="sng" algn="ctr">
-                      <a:solidFill>
-                        <a:srgbClr val="B1BBC8"/>
-                      </a:solidFill>
-                      <a:prstDash val="solid"/>
-                      <a:round/>
-                      <a:headEnd type="none" w="med" len="med"/>
-                      <a:tailEnd type="none" w="med" len="med"/>
-                    </a:lnR>
-                    <a:lnT w="12700" cap="flat" cmpd="sng" algn="ctr">
-                      <a:solidFill>
-                        <a:srgbClr val="B1BBC8"/>
-                      </a:solidFill>
-                      <a:prstDash val="solid"/>
-                      <a:round/>
-                      <a:headEnd type="none" w="med" len="med"/>
-                      <a:tailEnd type="none" w="med" len="med"/>
-                    </a:lnT>
-                    <a:lnB w="12700" cap="flat" cmpd="sng" algn="ctr">
-                      <a:solidFill>
-                        <a:srgbClr val="B1BBC8"/>
-                      </a:solidFill>
-                      <a:prstDash val="solid"/>
-                      <a:round/>
-                      <a:headEnd type="none" w="med" len="med"/>
-                      <a:tailEnd type="none" w="med" len="med"/>
-                    </a:lnB>
-                    <a:solidFill>
-                      <a:srgbClr val="FFFFFF"/>
-                    </a:solidFill>
-                  </a:tcPr>
-                </a:tc>
-              </a:tr>
-              <a:tr h="419100">
-                <a:tc>
-                  <a:txBody>
-                    <a:bodyPr/>
-                    <a:lstStyle/>
-                    <a:p>
                       <a:pPr indent="0" marL="0">
                         <a:buNone/>
                       </a:pPr>
                       <a:r>
-                        <a:rPr lang="en-US" sz="1450" b="1" dirty="0">
+                        <a:rPr lang="en-US" sz="1400" b="1" dirty="0">
                           <a:solidFill>
-                            <a:srgbClr val="1A2F57"/>
+                            <a:srgbClr val="2A4D88"/>
                           </a:solidFill>
                           <a:latin typeface="Calibri" pitchFamily="34" charset="0"/>
                           <a:ea typeface="Calibri" pitchFamily="34" charset="-122"/>
                           <a:cs typeface="Calibri" pitchFamily="34" charset="-120"/>
                         </a:rPr>
-                        <a:t>Citizen confirmation &amp; field learning</a:t>
+                        <a:t>Every work</a:t>
                       </a:r>
-                      <a:endParaRPr lang="en-US" sz="1450" dirty="0">
+                      <a:endParaRPr lang="en-US" sz="1400" dirty="0">
                         <a:latin typeface="Calibri" charset="0"/>
                         <a:ea typeface="Calibri" charset="0"/>
                         <a:cs typeface="Calibri" charset="0"/>
                       </a:endParaRPr>
                     </a:p>
                   </a:txBody>
-                  <a:tcPr marL="76200" marR="76200" marT="0" marB="0" anchor="ctr">
-                    <a:lnL w="12700" cap="flat" cmpd="sng" algn="ctr">
-                      <a:solidFill>
-                        <a:srgbClr val="B1BBC8"/>
-                      </a:solidFill>
-                      <a:prstDash val="solid"/>
-                      <a:round/>
-                      <a:headEnd type="none" w="med" len="med"/>
-                      <a:tailEnd type="none" w="med" len="med"/>
-                    </a:lnL>
-                    <a:lnR w="12700" cap="flat" cmpd="sng" algn="ctr">
-                      <a:solidFill>
-                        <a:srgbClr val="B1BBC8"/>
-                      </a:solidFill>
-                      <a:prstDash val="solid"/>
-                      <a:round/>
-                      <a:headEnd type="none" w="med" len="med"/>
-                      <a:tailEnd type="none" w="med" len="med"/>
-                    </a:lnR>
-                    <a:lnT w="12700" cap="flat" cmpd="sng" algn="ctr">
-                      <a:solidFill>
-                        <a:srgbClr val="B1BBC8"/>
-                      </a:solidFill>
-                      <a:prstDash val="solid"/>
-                      <a:round/>
-                      <a:headEnd type="none" w="med" len="med"/>
-                      <a:tailEnd type="none" w="med" len="med"/>
-                    </a:lnT>
-                    <a:lnB w="12700" cap="flat" cmpd="sng" algn="ctr">
-                      <a:solidFill>
-                        <a:srgbClr val="B1BBC8"/>
-                      </a:solidFill>
-                      <a:prstDash val="solid"/>
-                      <a:round/>
-                      <a:headEnd type="none" w="med" len="med"/>
-                      <a:tailEnd type="none" w="med" len="med"/>
-                    </a:lnB>
-                    <a:solidFill>
-                      <a:srgbClr val="EDF0F5"/>
-                    </a:solidFill>
-                  </a:tcPr>
-                </a:tc>
-                <a:tc>
-                  <a:txBody>
-                    <a:bodyPr/>
-                    <a:lstStyle/>
-                    <a:p>
-                      <a:pPr algn="ctr" indent="0" marL="0">
-                        <a:buNone/>
-                      </a:pPr>
-                      <a:r>
-                        <a:rPr lang="en-US" sz="1900" dirty="0">
-                          <a:solidFill>
-                            <a:srgbClr val="2E7D4F"/>
-                          </a:solidFill>
-                          <a:latin typeface="Segoe UI Symbol" pitchFamily="34" charset="0"/>
-                          <a:ea typeface="Segoe UI Symbol" pitchFamily="34" charset="-122"/>
-                          <a:cs typeface="Segoe UI Symbol" pitchFamily="34" charset="-120"/>
-                        </a:rPr>
-                        <a:t>✓</a:t>
-                      </a:r>
-                      <a:endParaRPr lang="en-US" sz="1900" dirty="0">
-                        <a:latin typeface="Segoe UI Symbol" charset="0"/>
-                        <a:ea typeface="Segoe UI Symbol" charset="0"/>
-                        <a:cs typeface="Segoe UI Symbol" charset="0"/>
-                      </a:endParaRPr>
-                    </a:p>
-                  </a:txBody>
-                  <a:tcPr marL="0" marR="0" marT="0" marB="0" anchor="ctr">
-                    <a:lnL w="12700" cap="flat" cmpd="sng" algn="ctr">
-                      <a:solidFill>
-                        <a:srgbClr val="B1BBC8"/>
-                      </a:solidFill>
-                      <a:prstDash val="solid"/>
-                      <a:round/>
-                      <a:headEnd type="none" w="med" len="med"/>
-                      <a:tailEnd type="none" w="med" len="med"/>
-                    </a:lnL>
-                    <a:lnR w="12700" cap="flat" cmpd="sng" algn="ctr">
-                      <a:solidFill>
-                        <a:srgbClr val="B1BBC8"/>
-                      </a:solidFill>
-                      <a:prstDash val="solid"/>
-                      <a:round/>
-                      <a:headEnd type="none" w="med" len="med"/>
-                      <a:tailEnd type="none" w="med" len="med"/>
-                    </a:lnR>
-                    <a:lnT w="12700" cap="flat" cmpd="sng" algn="ctr">
-                      <a:solidFill>
-                        <a:srgbClr val="B1BBC8"/>
-                      </a:solidFill>
-                      <a:prstDash val="solid"/>
-                      <a:round/>
-                      <a:headEnd type="none" w="med" len="med"/>
-                      <a:tailEnd type="none" w="med" len="med"/>
-                    </a:lnT>
-                    <a:lnB w="12700" cap="flat" cmpd="sng" algn="ctr">
-                      <a:solidFill>
-                        <a:srgbClr val="B1BBC8"/>
-                      </a:solidFill>
-                      <a:prstDash val="solid"/>
-                      <a:round/>
-                      <a:headEnd type="none" w="med" len="med"/>
-                      <a:tailEnd type="none" w="med" len="med"/>
-                    </a:lnB>
-                    <a:solidFill>
-                      <a:srgbClr val="FBF3E6"/>
-                    </a:solidFill>
-                  </a:tcPr>
-                </a:tc>
-                <a:tc>
-                  <a:txBody>
-                    <a:bodyPr/>
-                    <a:lstStyle/>
-                    <a:p>
-                      <a:pPr algn="ctr" indent="0" marL="0">
-                        <a:buNone/>
-                      </a:pPr>
-                      <a:r>
-                        <a:rPr lang="en-US" sz="1450" b="1" dirty="0">
-                          <a:solidFill>
-                            <a:srgbClr val="8A6D1F"/>
-                          </a:solidFill>
-                          <a:latin typeface="Calibri" pitchFamily="34" charset="0"/>
-                          <a:ea typeface="Calibri" pitchFamily="34" charset="-122"/>
-                          <a:cs typeface="Calibri" pitchFamily="34" charset="-120"/>
-                        </a:rPr>
-                        <a:t>Partial</a:t>
-                      </a:r>
-                      <a:endParaRPr lang="en-US" sz="1450" dirty="0">
-                        <a:latin typeface="Calibri" charset="0"/>
-                        <a:ea typeface="Calibri" charset="0"/>
-                        <a:cs typeface="Calibri" charset="0"/>
-                      </a:endParaRPr>
-                    </a:p>
-                  </a:txBody>
-                  <a:tcPr marL="0" marR="0" marT="0" marB="0" anchor="ctr">
-                    <a:lnL w="12700" cap="flat" cmpd="sng" algn="ctr">
-                      <a:solidFill>
-                        <a:srgbClr val="B1BBC8"/>
-                      </a:solidFill>
-                      <a:prstDash val="solid"/>
-                      <a:round/>
-                      <a:headEnd type="none" w="med" len="med"/>
-                      <a:tailEnd type="none" w="med" len="med"/>
-                    </a:lnL>
-                    <a:lnR w="12700" cap="flat" cmpd="sng" algn="ctr">
-                      <a:solidFill>
-                        <a:srgbClr val="B1BBC8"/>
-                      </a:solidFill>
-                      <a:prstDash val="solid"/>
-                      <a:round/>
-                      <a:headEnd type="none" w="med" len="med"/>
-                      <a:tailEnd type="none" w="med" len="med"/>
-                    </a:lnR>
-                    <a:lnT w="12700" cap="flat" cmpd="sng" algn="ctr">
-                      <a:solidFill>
-                        <a:srgbClr val="B1BBC8"/>
-                      </a:solidFill>
-                      <a:prstDash val="solid"/>
-                      <a:round/>
-                      <a:headEnd type="none" w="med" len="med"/>
-                      <a:tailEnd type="none" w="med" len="med"/>
-                    </a:lnT>
-                    <a:lnB w="12700" cap="flat" cmpd="sng" algn="ctr">
-                      <a:solidFill>
-                        <a:srgbClr val="B1BBC8"/>
-                      </a:solidFill>
-                      <a:prstDash val="solid"/>
-                      <a:round/>
-                      <a:headEnd type="none" w="med" len="med"/>
-                      <a:tailEnd type="none" w="med" len="med"/>
-                    </a:lnB>
-                    <a:solidFill>
-                      <a:srgbClr val="FFFFFF"/>
-                    </a:solidFill>
-                  </a:tcPr>
-                </a:tc>
-                <a:tc>
-                  <a:txBody>
-                    <a:bodyPr/>
-                    <a:lstStyle/>
-                    <a:p>
-                      <a:pPr algn="ctr" indent="0" marL="0">
-                        <a:buNone/>
-                      </a:pPr>
-                      <a:r>
-                        <a:rPr lang="en-US" sz="1900" dirty="0">
-                          <a:solidFill>
-                            <a:srgbClr val="B23B3B"/>
-                          </a:solidFill>
-                          <a:latin typeface="Segoe UI Symbol" pitchFamily="34" charset="0"/>
-                          <a:ea typeface="Segoe UI Symbol" pitchFamily="34" charset="-122"/>
-                          <a:cs typeface="Segoe UI Symbol" pitchFamily="34" charset="-120"/>
-                        </a:rPr>
-                        <a:t>✗</a:t>
-                      </a:r>
-                      <a:endParaRPr lang="en-US" sz="1900" dirty="0">
-                        <a:latin typeface="Segoe UI Symbol" charset="0"/>
-                        <a:ea typeface="Segoe UI Symbol" charset="0"/>
-                        <a:cs typeface="Segoe UI Symbol" charset="0"/>
-                      </a:endParaRPr>
-                    </a:p>
-                  </a:txBody>
-                  <a:tcPr marL="0" marR="0" marT="0" marB="0" anchor="ctr">
-                    <a:lnL w="12700" cap="flat" cmpd="sng" algn="ctr">
-                      <a:solidFill>
-                        <a:srgbClr val="B1BBC8"/>
-                      </a:solidFill>
-                      <a:prstDash val="solid"/>
-                      <a:round/>
-                      <a:headEnd type="none" w="med" len="med"/>
-                      <a:tailEnd type="none" w="med" len="med"/>
-                    </a:lnL>
-                    <a:lnR w="12700" cap="flat" cmpd="sng" algn="ctr">
-                      <a:solidFill>
-                        <a:srgbClr val="B1BBC8"/>
-                      </a:solidFill>
-                      <a:prstDash val="solid"/>
-                      <a:round/>
-                      <a:headEnd type="none" w="med" len="med"/>
-                      <a:tailEnd type="none" w="med" len="med"/>
-                    </a:lnR>
-                    <a:lnT w="12700" cap="flat" cmpd="sng" algn="ctr">
-                      <a:solidFill>
-                        <a:srgbClr val="B1BBC8"/>
-                      </a:solidFill>
-                      <a:prstDash val="solid"/>
-                      <a:round/>
-                      <a:headEnd type="none" w="med" len="med"/>
-                      <a:tailEnd type="none" w="med" len="med"/>
-                    </a:lnT>
-                    <a:lnB w="12700" cap="flat" cmpd="sng" algn="ctr">
-                      <a:solidFill>
-                        <a:srgbClr val="B1BBC8"/>
-                      </a:solidFill>
-                      <a:prstDash val="solid"/>
-                      <a:round/>
-                      <a:headEnd type="none" w="med" len="med"/>
-                      <a:tailEnd type="none" w="med" len="med"/>
-                    </a:lnB>
-                    <a:solidFill>
-                      <a:srgbClr val="FFFFFF"/>
-                    </a:solidFill>
-                  </a:tcPr>
-                </a:tc>
-                <a:tc>
-                  <a:txBody>
-                    <a:bodyPr/>
-                    <a:lstStyle/>
-                    <a:p>
-                      <a:pPr algn="ctr" indent="0" marL="0">
-                        <a:buNone/>
-                      </a:pPr>
-                      <a:r>
-                        <a:rPr lang="en-US" sz="1900" dirty="0">
-                          <a:solidFill>
-                            <a:srgbClr val="B23B3B"/>
-                          </a:solidFill>
-                          <a:latin typeface="Segoe UI Symbol" pitchFamily="34" charset="0"/>
-                          <a:ea typeface="Segoe UI Symbol" pitchFamily="34" charset="-122"/>
-                          <a:cs typeface="Segoe UI Symbol" pitchFamily="34" charset="-120"/>
-                        </a:rPr>
-                        <a:t>✗</a:t>
-                      </a:r>
-                      <a:endParaRPr lang="en-US" sz="1900" dirty="0">
-                        <a:latin typeface="Segoe UI Symbol" charset="0"/>
-                        <a:ea typeface="Segoe UI Symbol" charset="0"/>
-                        <a:cs typeface="Segoe UI Symbol" charset="0"/>
-                      </a:endParaRPr>
-                    </a:p>
-                  </a:txBody>
-                  <a:tcPr marL="0" marR="0" marT="0" marB="0" anchor="ctr">
+                  <a:tcPr marL="101600" marR="76200" marT="0" marB="0" anchor="ctr">
                     <a:lnL w="12700" cap="flat" cmpd="sng" algn="ctr">
                       <a:solidFill>
                         <a:srgbClr val="B1BBC8"/>

</xml_diff>

<commit_message>
Deck: impact slide tied to the agents; fund flow wording matches the trial
- Slide 5: stakeholder and benefit bullets now name what the agents actually do (split works,
  repeats, sanction delays from certificates, photo/GPS checks, stuck works); "fairer spread of
  works" and "built right first time" removed - no agent delivers them
- "45-day window" replaced (the sanction limit is 75 days in the 2016 text; 2023 unconfirmed)
- Fund Flow: "year-end rush" dropped - the trial showed it is a portal cycle

Co-Authored-By: Claude Opus 5.5 (1M context) <noreply@anthropic.com>
</commit_message>
<xml_diff>
--- a/docs/deck/DRISHTI_SIH26102_v2.pptx
+++ b/docs/deck/DRISHTI_SIH26102_v2.pptx
@@ -595,7 +595,7 @@
           <a:p>
             <a:r>
               <a:rPr lang="en-US" dirty="0"/>
-              <a:t>Twelve agents in four stages of a work's life. Each maps to a problem the PS names or a CAG audit found: cost overruns (Cost, Document), duplicate works (Duplicate &amp; Split), delayed projects (Delay Prediction), misuse of funds (Photo Forensics, Geo-Location, Document, Fund Flow, Contractor Network), non-compliance (Eligibility), early warning (Delay Prediction, pre-sanction checks). Satellite runs only for big works (ponds, long roads) and only after it passes a go/no-go test on real works. 45-day window: the team's reading of the MPLADS Guidelines 2023 — confirm against the 2023 text (the 2016 edition says sanction within 75 days, rejection within 45).</a:t>
+              <a:t>Twelve agents in four stages of a work's life. Each maps to a problem the PS names or a CAG audit found: cost overruns (Cost, Document), duplicate works (Duplicate &amp; Split), delayed projects (Delay Prediction), misuse of funds (Photo Forensics, Geo-Location, Document, Fund Flow, Contractor Network), non-compliance (Eligibility), early warning (Delay Prediction, pre-sanction checks). Satellite runs only for big works (ponds, long roads) and only after it passes a go/no-go test on real works. Sanction window: the 2016 Guidelines say sanction within 75 days (rejection within 45); on 211 real UP certificates the median was 68 days and 16% were sanctioned after 75 days. Confirm the 2023 wording.</a:t>
             </a:r>
             <a:endParaRPr lang="en-US" dirty="0"/>
           </a:p>
@@ -3670,7 +3670,7 @@
                 <a:ea typeface="Calibri" pitchFamily="34" charset="-122"/>
                 <a:cs typeface="Calibri" pitchFamily="34" charset="-120"/>
               </a:rPr>
-              <a:t>pre-sanction check inside the 45-day window.</a:t>
+              <a:t>eligibility, duplicate &amp; cost checks before sanction.</a:t>
             </a:r>
             <a:endParaRPr lang="en-US" sz="1820" dirty="0"/>
           </a:p>
@@ -4820,7 +4820,7 @@
                 <a:ea typeface="Calibri" pitchFamily="34" charset="-122"/>
                 <a:cs typeface="Calibri" pitchFamily="34" charset="-120"/>
               </a:rPr>
-              <a:t> — idle funds, year-end rush</a:t>
+              <a:t> — idle funds, sanctions waiting too long</a:t>
             </a:r>
             <a:endParaRPr lang="en-US" sz="1450" dirty="0"/>
           </a:p>
@@ -8723,7 +8723,7 @@
                 <a:ea typeface="Calibri" pitchFamily="34" charset="-122"/>
                 <a:cs typeface="Calibri" pitchFamily="34" charset="-120"/>
               </a:rPr>
-              <a:t>idle funds, year-end rush</a:t>
+              <a:t>idle funds, sanctions waiting too long</a:t>
             </a:r>
             <a:endParaRPr lang="en-US" sz="1350" dirty="0"/>
           </a:p>
@@ -13219,7 +13219,7 @@
                 <a:ea typeface="Calibri" pitchFamily="34" charset="-122"/>
                 <a:cs typeface="Calibri" pitchFamily="34" charset="-120"/>
               </a:rPr>
-              <a:t>Spot systemic issues &amp; guideline gaps</a:t>
+              <a:t>Spot patterns: split works, repeats, delays</a:t>
             </a:r>
             <a:endParaRPr lang="en-US" sz="1750" dirty="0"/>
           </a:p>
@@ -13240,7 +13240,7 @@
                 <a:ea typeface="Calibri" pitchFamily="34" charset="-122"/>
                 <a:cs typeface="Calibri" pitchFamily="34" charset="-120"/>
               </a:rPr>
-              <a:t>Evidence-backed reports for Parliament</a:t>
+              <a:t>Sanction backlog &amp; fund use by term</a:t>
             </a:r>
             <a:endParaRPr lang="en-US" sz="1750" dirty="0"/>
           </a:p>
@@ -13409,7 +13409,7 @@
                 <a:ea typeface="Calibri" pitchFamily="34" charset="-122"/>
                 <a:cs typeface="Calibri" pitchFamily="34" charset="-120"/>
               </a:rPr>
-              <a:t>District &amp; agency league tables</a:t>
+              <a:t>District &amp; agency track records</a:t>
             </a:r>
             <a:endParaRPr lang="en-US" sz="1750" dirty="0"/>
           </a:p>
@@ -13430,7 +13430,7 @@
                 <a:ea typeface="Calibri" pitchFamily="34" charset="-122"/>
                 <a:cs typeface="Calibri" pitchFamily="34" charset="-120"/>
               </a:rPr>
-              <a:t>Escalate stalled or high-risk works</a:t>
+              <a:t>Escalate stuck or high-risk works</a:t>
             </a:r>
             <a:endParaRPr lang="en-US" sz="1750" dirty="0"/>
           </a:p>
@@ -13451,7 +13451,7 @@
                 <a:ea typeface="Calibri" pitchFamily="34" charset="-122"/>
                 <a:cs typeface="Calibri" pitchFamily="34" charset="-120"/>
               </a:rPr>
-              <a:t>Track follow-up on every alert</a:t>
+              <a:t>Sanction delays read from certificates</a:t>
             </a:r>
             <a:endParaRPr lang="en-US" sz="1750" dirty="0"/>
           </a:p>
@@ -13620,7 +13620,7 @@
                 <a:ea typeface="Calibri" pitchFamily="34" charset="-122"/>
                 <a:cs typeface="Calibri" pitchFamily="34" charset="-120"/>
               </a:rPr>
-              <a:t>Daily ranked alert queue with evidence</a:t>
+              <a:t>Daily ranked review queue with evidence</a:t>
             </a:r>
             <a:endParaRPr lang="en-US" sz="1750" dirty="0"/>
           </a:p>
@@ -13662,7 +13662,7 @@
                 <a:ea typeface="Calibri" pitchFamily="34" charset="-122"/>
                 <a:cs typeface="Calibri" pitchFamily="34" charset="-120"/>
               </a:rPr>
-              <a:t>Pre-sanction check in the 45-day window</a:t>
+              <a:t>Pre-sanction eligibility &amp; cost checks</a:t>
             </a:r>
             <a:endParaRPr lang="en-US" sz="1750" dirty="0"/>
           </a:p>
@@ -13683,7 +13683,7 @@
                 <a:ea typeface="Calibri" pitchFamily="34" charset="-122"/>
                 <a:cs typeface="Calibri" pitchFamily="34" charset="-120"/>
               </a:rPr>
-              <a:t>One-click PDF evidence brief</a:t>
+              <a:t>Photo, GPS &amp; certificate checks</a:t>
             </a:r>
             <a:endParaRPr lang="en-US" sz="1750" dirty="0"/>
           </a:p>
@@ -13852,7 +13852,7 @@
                 <a:ea typeface="Calibri" pitchFamily="34" charset="-122"/>
                 <a:cs typeface="Calibri" pitchFamily="34" charset="-120"/>
               </a:rPr>
-              <a:t>Early warning on delays &amp; idle funds</a:t>
+              <a:t>Early warning on stuck works &amp; waiting sanctions</a:t>
             </a:r>
             <a:endParaRPr lang="en-US" sz="1750" dirty="0"/>
           </a:p>
@@ -14085,7 +14085,7 @@
                 <a:ea typeface="Calibri" pitchFamily="34" charset="-122"/>
                 <a:cs typeface="Calibri" pitchFamily="34" charset="-120"/>
               </a:rPr>
-              <a:t>Faster delivery of community assets</a:t>
+              <a:t>Assets that truly exist, where claimed</a:t>
             </a:r>
             <a:endParaRPr lang="en-US" sz="1700" dirty="0"/>
           </a:p>
@@ -14103,7 +14103,7 @@
                 <a:ea typeface="Calibri" pitchFamily="34" charset="-122"/>
                 <a:cs typeface="Calibri" pitchFamily="34" charset="-120"/>
               </a:rPr>
-              <a:t>Public trust through transparency</a:t>
+              <a:t>Rules followed: ineligible works caught early</a:t>
             </a:r>
             <a:endParaRPr lang="en-US" sz="1700" dirty="0"/>
           </a:p>
@@ -14121,7 +14121,7 @@
                 <a:ea typeface="Calibri" pitchFamily="34" charset="-122"/>
                 <a:cs typeface="Calibri" pitchFamily="34" charset="-120"/>
               </a:rPr>
-              <a:t>Citizens get assets that truly exist</a:t>
+              <a:t>Stuck works surfaced, delivered faster</a:t>
             </a:r>
             <a:endParaRPr lang="en-US" sz="1700" dirty="0"/>
           </a:p>
@@ -14139,7 +14139,7 @@
                 <a:ea typeface="Calibri" pitchFamily="34" charset="-122"/>
                 <a:cs typeface="Calibri" pitchFamily="34" charset="-120"/>
               </a:rPr>
-              <a:t>Fairer spread of works across areas</a:t>
+              <a:t>Public trust through transparency</a:t>
             </a:r>
             <a:endParaRPr lang="en-US" sz="1700" dirty="0"/>
           </a:p>
@@ -14309,7 +14309,7 @@
                 <a:ea typeface="Calibri" pitchFamily="34" charset="-122"/>
                 <a:cs typeface="Calibri" pitchFamily="34" charset="-120"/>
               </a:rPr>
-              <a:t>Targeted visits save officer time</a:t>
+              <a:t>Catch split works, repeats &amp; padded costs</a:t>
             </a:r>
             <a:endParaRPr lang="en-US" sz="1700" dirty="0"/>
           </a:p>
@@ -14327,7 +14327,7 @@
                 <a:ea typeface="Calibri" pitchFamily="34" charset="-122"/>
                 <a:cs typeface="Calibri" pitchFamily="34" charset="-120"/>
               </a:rPr>
-              <a:t>Catch reused photos &amp; padded bills</a:t>
+              <a:t>Catch reused photos &amp; bills that don't add up</a:t>
             </a:r>
             <a:endParaRPr lang="en-US" sz="1700" dirty="0"/>
           </a:p>
@@ -14345,7 +14345,7 @@
                 <a:ea typeface="Calibri" pitchFamily="34" charset="-122"/>
                 <a:cs typeface="Calibri" pitchFamily="34" charset="-120"/>
               </a:rPr>
-              <a:t>Fewer cost overruns and rework</a:t>
+              <a:t>Targeted visits save officer time</a:t>
             </a:r>
             <a:endParaRPr lang="en-US" sz="1700" dirty="0"/>
           </a:p>
@@ -14515,7 +14515,7 @@
                 <a:ea typeface="Calibri" pitchFamily="34" charset="-122"/>
                 <a:cs typeface="Calibri" pitchFamily="34" charset="-120"/>
               </a:rPr>
-              <a:t>Fewer wasted site trips and fuel</a:t>
+              <a:t>Remote checks via photos &amp; GPS stamps</a:t>
             </a:r>
             <a:endParaRPr lang="en-US" sz="1700" dirty="0"/>
           </a:p>
@@ -14533,7 +14533,7 @@
                 <a:ea typeface="Calibri" pitchFamily="34" charset="-122"/>
                 <a:cs typeface="Calibri" pitchFamily="34" charset="-120"/>
               </a:rPr>
-              <a:t>Durable assets built right first time</a:t>
+              <a:t>Fewer wasted site trips and fuel</a:t>
             </a:r>
             <a:endParaRPr lang="en-US" sz="1700" dirty="0"/>
           </a:p>

</xml_diff>